<commit_message>
Link the evidence slide to the repo, and drop the generic how-to slide
Evidence & Artifacts now carries clickable links to the branch, the write-up,
the run-log definition and the dashboard source, so a reviewer can reach the
proof without being given Snowflake access. Display text is kept short because
the template's link boxes are ~2in wide; the URL is attached as a hyperlink.

Labels retitled to match what exists: this is a branch, not a PR, and the
'demo recording' slot holds the write-up.
</commit_message>
<xml_diff>
--- a/docs/AI_Capstone_L2_Shamirna_Antony.pptx
+++ b/docs/AI_Capstone_L2_Shamirna_Antony.pptx
@@ -5,22 +5,21 @@
     <p:sldMasterId id="2147483648" r:id="rId4"/>
   </p:sldMasterIdLst>
   <p:notesMasterIdLst>
-    <p:notesMasterId r:id="rId18"/>
+    <p:notesMasterId r:id="rId17"/>
   </p:notesMasterIdLst>
   <p:sldIdLst>
     <p:sldId id="256" r:id="rId5"/>
-    <p:sldId id="257" r:id="rId6"/>
-    <p:sldId id="258" r:id="rId7"/>
-    <p:sldId id="259" r:id="rId8"/>
-    <p:sldId id="260" r:id="rId9"/>
-    <p:sldId id="261" r:id="rId10"/>
-    <p:sldId id="262" r:id="rId11"/>
-    <p:sldId id="263" r:id="rId12"/>
-    <p:sldId id="264" r:id="rId13"/>
-    <p:sldId id="265" r:id="rId14"/>
-    <p:sldId id="266" r:id="rId15"/>
-    <p:sldId id="268" r:id="rId16"/>
-    <p:sldId id="267" r:id="rId17"/>
+    <p:sldId id="258" r:id="rId6"/>
+    <p:sldId id="259" r:id="rId7"/>
+    <p:sldId id="260" r:id="rId8"/>
+    <p:sldId id="261" r:id="rId9"/>
+    <p:sldId id="262" r:id="rId10"/>
+    <p:sldId id="263" r:id="rId11"/>
+    <p:sldId id="264" r:id="rId12"/>
+    <p:sldId id="265" r:id="rId13"/>
+    <p:sldId id="266" r:id="rId14"/>
+    <p:sldId id="268" r:id="rId15"/>
+    <p:sldId id="267" r:id="rId16"/>
   </p:sldIdLst>
   <p:sldSz cx="9144000" cy="5143500" type="screen16x9"/>
   <p:notesSz cx="5143500" cy="9144000"/>
@@ -576,90 +575,6 @@
             <a:fld id="{F7021451-1387-4CA6-816F-3879F97B5CBC}" type="slidenum">
               <a:rPr lang="en-US"/>
               <a:t>12</a:t>
-            </a:fld>
-            <a:endParaRPr lang="en-US"/>
-          </a:p>
-        </p:txBody>
-      </p:sp>
-    </p:spTree>
-    <p:extLst>
-      <p:ext uri="{BB962C8B-B14F-4D97-AF65-F5344CB8AC3E}">
-        <p14:creationId xmlns:p14="http://schemas.microsoft.com/office/powerpoint/2010/main" val="1024086991"/>
-      </p:ext>
-    </p:extLst>
-  </p:cSld>
-  <p:clrMapOvr>
-    <a:masterClrMapping/>
-  </p:clrMapOvr>
-</p:notes>
-</file>
-
-<file path=ppt/notesSlides/notesSlide13.xml><?xml version="1.0" encoding="utf-8"?>
-<p:notes xmlns:a="http://schemas.openxmlformats.org/drawingml/2006/main" xmlns:r="http://schemas.openxmlformats.org/officeDocument/2006/relationships" xmlns:p="http://schemas.openxmlformats.org/presentationml/2006/main">
-  <p:cSld>
-    <p:spTree>
-      <p:nvGrpSpPr>
-        <p:cNvPr id="1" name=""/>
-        <p:cNvGrpSpPr/>
-        <p:nvPr/>
-      </p:nvGrpSpPr>
-      <p:grpSpPr>
-        <a:xfrm>
-          <a:off x="0" y="0"/>
-          <a:ext cx="0" cy="0"/>
-          <a:chOff x="0" y="0"/>
-          <a:chExt cx="0" cy="0"/>
-        </a:xfrm>
-      </p:grpSpPr>
-      <p:sp>
-        <p:nvSpPr>
-          <p:cNvPr id="2" name="Slide Image Placeholder 1"/>
-          <p:cNvSpPr>
-            <a:spLocks noGrp="1" noRot="1" noChangeAspect="1"/>
-          </p:cNvSpPr>
-          <p:nvPr>
-            <p:ph type="sldImg"/>
-          </p:nvPr>
-        </p:nvSpPr>
-        <p:spPr/>
-      </p:sp>
-      <p:sp>
-        <p:nvSpPr>
-          <p:cNvPr id="3" name="Notes Placeholder 2"/>
-          <p:cNvSpPr>
-            <a:spLocks noGrp="1"/>
-          </p:cNvSpPr>
-          <p:nvPr>
-            <p:ph type="body" idx="1"/>
-          </p:nvPr>
-        </p:nvSpPr>
-        <p:spPr/>
-        <p:txBody>
-          <a:bodyPr/>
-          <a:lstStyle/>
-          <a:p>
-            <a:endParaRPr lang="en-US"/>
-          </a:p>
-        </p:txBody>
-      </p:sp>
-      <p:sp>
-        <p:nvSpPr>
-          <p:cNvPr id="4" name="Slide Number Placeholder 3"/>
-          <p:cNvSpPr>
-            <a:spLocks noGrp="1"/>
-          </p:cNvSpPr>
-          <p:nvPr>
-            <p:ph type="sldNum" sz="quarter" idx="10"/>
-          </p:nvPr>
-        </p:nvSpPr>
-        <p:spPr/>
-        <p:txBody>
-          <a:bodyPr/>
-          <a:lstStyle/>
-          <a:p>
-            <a:fld id="{F7021451-1387-4CA6-816F-3879F97B5CBC}" type="slidenum">
-              <a:rPr lang="en-US"/>
-              <a:t>13</a:t>
             </a:fld>
             <a:endParaRPr lang="en-US"/>
           </a:p>
@@ -2017,7 +1932,7 @@
                 <a:ea typeface="Calibri"/>
                 <a:cs typeface="Calibri"/>
               </a:rPr>
-              <a:t>Name: Shamirna Antony                    Date: ____________________</a:t>
+              <a:t>Name: Shamirna Antony                    Date: 07 Sep 2026</a:t>
             </a:r>
             <a:endParaRPr lang="en-US" sz="1300" dirty="0">
               <a:latin typeface="Calibri"/>
@@ -2075,1748 +1990,6 @@
 </file>
 
 <file path=ppt/slides/slide10.xml><?xml version="1.0" encoding="utf-8"?>
-<p:sld xmlns:a="http://schemas.openxmlformats.org/drawingml/2006/main" xmlns:r="http://schemas.openxmlformats.org/officeDocument/2006/relationships" xmlns:p="http://schemas.openxmlformats.org/presentationml/2006/main">
-  <p:cSld name="Slide 10">
-    <p:bg>
-      <p:bgPr>
-        <a:solidFill>
-          <a:srgbClr val="FFFFFF"/>
-        </a:solidFill>
-        <a:effectLst/>
-      </p:bgPr>
-    </p:bg>
-    <p:spTree>
-      <p:nvGrpSpPr>
-        <p:cNvPr id="1" name=""/>
-        <p:cNvGrpSpPr/>
-        <p:nvPr/>
-      </p:nvGrpSpPr>
-      <p:grpSpPr>
-        <a:xfrm>
-          <a:off x="0" y="0"/>
-          <a:ext cx="0" cy="0"/>
-          <a:chOff x="0" y="0"/>
-          <a:chExt cx="0" cy="0"/>
-        </a:xfrm>
-      </p:grpSpPr>
-      <p:sp>
-        <p:nvSpPr>
-          <p:cNvPr id="2" name="Text 0"/>
-          <p:cNvSpPr/>
-          <p:nvPr/>
-        </p:nvSpPr>
-        <p:spPr>
-          <a:xfrm>
-            <a:off x="457200" y="274320"/>
-            <a:ext cx="7498080" cy="548640"/>
-          </a:xfrm>
-          <a:prstGeom prst="rect">
-            <a:avLst/>
-          </a:prstGeom>
-          <a:noFill/>
-          <a:ln/>
-        </p:spPr>
-        <p:txBody>
-          <a:bodyPr wrap="square" rtlCol="0" anchor="ctr"/>
-          <a:lstStyle/>
-          <a:p>
-            <a:pPr marL="0" indent="0" algn="l">
-              <a:buNone/>
-            </a:pPr>
-            <a:r>
-              <a:rPr lang="en-US" sz="2600" b="1">
-                <a:solidFill>
-                  <a:srgbClr val="024879"/>
-                </a:solidFill>
-                <a:latin typeface="Arial" pitchFamily="34" charset="0"/>
-                <a:ea typeface="Arial" pitchFamily="34" charset="-122"/>
-                <a:cs typeface="Arial" pitchFamily="34" charset="-120"/>
-              </a:rPr>
-              <a:t>The Rubric — 5 Topics</a:t>
-            </a:r>
-            <a:endParaRPr lang="en-US" sz="2600"/>
-          </a:p>
-        </p:txBody>
-      </p:sp>
-      <p:pic>
-        <p:nvPicPr>
-          <p:cNvPr id="3" name="Image 0" descr="preencoded.png"/>
-          <p:cNvPicPr>
-            <a:picLocks noChangeAspect="1"/>
-          </p:cNvPicPr>
-          <p:nvPr/>
-        </p:nvPicPr>
-        <p:blipFill>
-          <a:blip r:embed="rId3"/>
-          <a:stretch>
-            <a:fillRect/>
-          </a:stretch>
-        </p:blipFill>
-        <p:spPr>
-          <a:xfrm>
-            <a:off x="7818120" y="292608"/>
-            <a:ext cx="914400" cy="274730"/>
-          </a:xfrm>
-          <a:prstGeom prst="rect">
-            <a:avLst/>
-          </a:prstGeom>
-        </p:spPr>
-      </p:pic>
-      <p:sp>
-        <p:nvSpPr>
-          <p:cNvPr id="4" name="Text 1"/>
-          <p:cNvSpPr/>
-          <p:nvPr/>
-        </p:nvSpPr>
-        <p:spPr>
-          <a:xfrm>
-            <a:off x="457200" y="896112"/>
-            <a:ext cx="8229600" cy="274320"/>
-          </a:xfrm>
-          <a:prstGeom prst="rect">
-            <a:avLst/>
-          </a:prstGeom>
-          <a:noFill/>
-          <a:ln/>
-        </p:spPr>
-        <p:txBody>
-          <a:bodyPr wrap="square" rtlCol="0" anchor="ctr"/>
-          <a:lstStyle/>
-          <a:p>
-            <a:pPr marL="0" indent="0">
-              <a:buNone/>
-            </a:pPr>
-            <a:r>
-              <a:rPr lang="en-US" sz="1200" i="1">
-                <a:solidFill>
-                  <a:srgbClr val="5A6B72"/>
-                </a:solidFill>
-                <a:latin typeface="Calibri" pitchFamily="34" charset="0"/>
-                <a:ea typeface="Calibri" pitchFamily="34" charset="-122"/>
-                <a:cs typeface="Calibri" pitchFamily="34" charset="-120"/>
-              </a:rPr>
-              <a:t>Each topic scored 0–30. Demonstrate at least 3. Clear at 70 / 150.</a:t>
-            </a:r>
-            <a:endParaRPr lang="en-US" sz="1200"/>
-          </a:p>
-        </p:txBody>
-      </p:sp>
-      <p:graphicFrame>
-        <p:nvGraphicFramePr>
-          <p:cNvPr id="11" name="Table 0"/>
-          <p:cNvGraphicFramePr>
-            <a:graphicFrameLocks noGrp="1"/>
-          </p:cNvGraphicFramePr>
-          <p:nvPr>
-            <p:extLst>
-              <p:ext uri="{D42A27DB-BD31-4B8C-83A1-F6EECF244321}">
-                <p14:modId xmlns:p14="http://schemas.microsoft.com/office/powerpoint/2010/main" val="1579011935"/>
-              </p:ext>
-            </p:extLst>
-          </p:nvPr>
-        </p:nvGraphicFramePr>
-        <p:xfrm>
-          <a:off x="457200" y="1234440"/>
-          <a:ext cx="8229600" cy="3200400"/>
-        </p:xfrm>
-        <a:graphic>
-          <a:graphicData uri="http://schemas.openxmlformats.org/drawingml/2006/table">
-            <a:tbl>
-              <a:tblPr/>
-              <a:tblGrid>
-                <a:gridCol w="2468880">
-                  <a:extLst>
-                    <a:ext uri="{9D8B030D-6E8A-4147-A177-3AD203B41FA5}">
-                      <a16:colId xmlns:a16="http://schemas.microsoft.com/office/drawing/2014/main" val="20000"/>
-                    </a:ext>
-                  </a:extLst>
-                </a:gridCol>
-                <a:gridCol w="5029200">
-                  <a:extLst>
-                    <a:ext uri="{9D8B030D-6E8A-4147-A177-3AD203B41FA5}">
-                      <a16:colId xmlns:a16="http://schemas.microsoft.com/office/drawing/2014/main" val="20001"/>
-                    </a:ext>
-                  </a:extLst>
-                </a:gridCol>
-                <a:gridCol w="731520">
-                  <a:extLst>
-                    <a:ext uri="{9D8B030D-6E8A-4147-A177-3AD203B41FA5}">
-                      <a16:colId xmlns:a16="http://schemas.microsoft.com/office/drawing/2014/main" val="20002"/>
-                    </a:ext>
-                  </a:extLst>
-                </a:gridCol>
-              </a:tblGrid>
-              <a:tr h="365760">
-                <a:tc>
-                  <a:txBody>
-                    <a:bodyPr/>
-                    <a:lstStyle/>
-                    <a:p>
-                      <a:pPr marL="0" indent="0">
-                        <a:buNone/>
-                      </a:pPr>
-                      <a:r>
-                        <a:rPr lang="en-US" sz="1100" b="1">
-                          <a:solidFill>
-                            <a:srgbClr val="FFFFFF"/>
-                          </a:solidFill>
-                          <a:latin typeface="Calibri" pitchFamily="34" charset="0"/>
-                          <a:ea typeface="Calibri" pitchFamily="34" charset="-122"/>
-                          <a:cs typeface="Calibri" pitchFamily="34" charset="-120"/>
-                        </a:rPr>
-                        <a:t>Competency topic</a:t>
-                      </a:r>
-                      <a:endParaRPr lang="en-US" sz="1100">
-                        <a:latin typeface="Calibri" charset="0"/>
-                        <a:ea typeface="Calibri" charset="0"/>
-                        <a:cs typeface="Calibri" charset="0"/>
-                      </a:endParaRPr>
-                    </a:p>
-                  </a:txBody>
-                  <a:tcPr anchor="ctr">
-                    <a:lnL w="6350" cap="flat" cmpd="sng" algn="ctr">
-                      <a:solidFill>
-                        <a:srgbClr val="B7C4CC"/>
-                      </a:solidFill>
-                      <a:prstDash val="solid"/>
-                      <a:round/>
-                      <a:headEnd type="none" w="med" len="med"/>
-                      <a:tailEnd type="none" w="med" len="med"/>
-                    </a:lnL>
-                    <a:lnR w="6350" cap="flat" cmpd="sng" algn="ctr">
-                      <a:solidFill>
-                        <a:srgbClr val="B7C4CC"/>
-                      </a:solidFill>
-                      <a:prstDash val="solid"/>
-                      <a:round/>
-                      <a:headEnd type="none" w="med" len="med"/>
-                      <a:tailEnd type="none" w="med" len="med"/>
-                    </a:lnR>
-                    <a:lnT w="6350" cap="flat" cmpd="sng" algn="ctr">
-                      <a:solidFill>
-                        <a:srgbClr val="B7C4CC"/>
-                      </a:solidFill>
-                      <a:prstDash val="solid"/>
-                      <a:round/>
-                      <a:headEnd type="none" w="med" len="med"/>
-                      <a:tailEnd type="none" w="med" len="med"/>
-                    </a:lnT>
-                    <a:lnB w="6350" cap="flat" cmpd="sng" algn="ctr">
-                      <a:solidFill>
-                        <a:srgbClr val="B7C4CC"/>
-                      </a:solidFill>
-                      <a:prstDash val="solid"/>
-                      <a:round/>
-                      <a:headEnd type="none" w="med" len="med"/>
-                      <a:tailEnd type="none" w="med" len="med"/>
-                    </a:lnB>
-                    <a:solidFill>
-                      <a:srgbClr val="075056"/>
-                    </a:solidFill>
-                  </a:tcPr>
-                </a:tc>
-                <a:tc>
-                  <a:txBody>
-                    <a:bodyPr/>
-                    <a:lstStyle/>
-                    <a:p>
-                      <a:pPr marL="0" indent="0">
-                        <a:buNone/>
-                      </a:pPr>
-                      <a:r>
-                        <a:rPr lang="en-US" sz="1100" b="1">
-                          <a:solidFill>
-                            <a:srgbClr val="FFFFFF"/>
-                          </a:solidFill>
-                          <a:latin typeface="Calibri" pitchFamily="34" charset="0"/>
-                          <a:ea typeface="Calibri" pitchFamily="34" charset="-122"/>
-                          <a:cs typeface="Calibri" pitchFamily="34" charset="-120"/>
-                        </a:rPr>
-                        <a:t>What earns top marks (25–30)</a:t>
-                      </a:r>
-                      <a:endParaRPr lang="en-US" sz="1100">
-                        <a:latin typeface="Calibri" charset="0"/>
-                        <a:ea typeface="Calibri" charset="0"/>
-                        <a:cs typeface="Calibri" charset="0"/>
-                      </a:endParaRPr>
-                    </a:p>
-                  </a:txBody>
-                  <a:tcPr anchor="ctr">
-                    <a:lnL w="6350" cap="flat" cmpd="sng" algn="ctr">
-                      <a:solidFill>
-                        <a:srgbClr val="B7C4CC"/>
-                      </a:solidFill>
-                      <a:prstDash val="solid"/>
-                      <a:round/>
-                      <a:headEnd type="none" w="med" len="med"/>
-                      <a:tailEnd type="none" w="med" len="med"/>
-                    </a:lnL>
-                    <a:lnR w="6350" cap="flat" cmpd="sng" algn="ctr">
-                      <a:solidFill>
-                        <a:srgbClr val="B7C4CC"/>
-                      </a:solidFill>
-                      <a:prstDash val="solid"/>
-                      <a:round/>
-                      <a:headEnd type="none" w="med" len="med"/>
-                      <a:tailEnd type="none" w="med" len="med"/>
-                    </a:lnR>
-                    <a:lnT w="6350" cap="flat" cmpd="sng" algn="ctr">
-                      <a:solidFill>
-                        <a:srgbClr val="B7C4CC"/>
-                      </a:solidFill>
-                      <a:prstDash val="solid"/>
-                      <a:round/>
-                      <a:headEnd type="none" w="med" len="med"/>
-                      <a:tailEnd type="none" w="med" len="med"/>
-                    </a:lnT>
-                    <a:lnB w="6350" cap="flat" cmpd="sng" algn="ctr">
-                      <a:solidFill>
-                        <a:srgbClr val="B7C4CC"/>
-                      </a:solidFill>
-                      <a:prstDash val="solid"/>
-                      <a:round/>
-                      <a:headEnd type="none" w="med" len="med"/>
-                      <a:tailEnd type="none" w="med" len="med"/>
-                    </a:lnB>
-                    <a:solidFill>
-                      <a:srgbClr val="075056"/>
-                    </a:solidFill>
-                  </a:tcPr>
-                </a:tc>
-                <a:tc>
-                  <a:txBody>
-                    <a:bodyPr/>
-                    <a:lstStyle/>
-                    <a:p>
-                      <a:pPr marL="0" indent="0" algn="ctr">
-                        <a:buNone/>
-                      </a:pPr>
-                      <a:r>
-                        <a:rPr lang="en-US" sz="1100" b="1">
-                          <a:solidFill>
-                            <a:srgbClr val="FFFFFF"/>
-                          </a:solidFill>
-                          <a:latin typeface="Calibri" pitchFamily="34" charset="0"/>
-                          <a:ea typeface="Calibri" pitchFamily="34" charset="-122"/>
-                          <a:cs typeface="Calibri" pitchFamily="34" charset="-120"/>
-                        </a:rPr>
-                        <a:t>Max</a:t>
-                      </a:r>
-                      <a:endParaRPr lang="en-US" sz="1100">
-                        <a:latin typeface="Calibri" charset="0"/>
-                        <a:ea typeface="Calibri" charset="0"/>
-                        <a:cs typeface="Calibri" charset="0"/>
-                      </a:endParaRPr>
-                    </a:p>
-                  </a:txBody>
-                  <a:tcPr anchor="ctr">
-                    <a:lnL w="6350" cap="flat" cmpd="sng" algn="ctr">
-                      <a:solidFill>
-                        <a:srgbClr val="B7C4CC"/>
-                      </a:solidFill>
-                      <a:prstDash val="solid"/>
-                      <a:round/>
-                      <a:headEnd type="none" w="med" len="med"/>
-                      <a:tailEnd type="none" w="med" len="med"/>
-                    </a:lnL>
-                    <a:lnR w="6350" cap="flat" cmpd="sng" algn="ctr">
-                      <a:solidFill>
-                        <a:srgbClr val="B7C4CC"/>
-                      </a:solidFill>
-                      <a:prstDash val="solid"/>
-                      <a:round/>
-                      <a:headEnd type="none" w="med" len="med"/>
-                      <a:tailEnd type="none" w="med" len="med"/>
-                    </a:lnR>
-                    <a:lnT w="6350" cap="flat" cmpd="sng" algn="ctr">
-                      <a:solidFill>
-                        <a:srgbClr val="B7C4CC"/>
-                      </a:solidFill>
-                      <a:prstDash val="solid"/>
-                      <a:round/>
-                      <a:headEnd type="none" w="med" len="med"/>
-                      <a:tailEnd type="none" w="med" len="med"/>
-                    </a:lnT>
-                    <a:lnB w="6350" cap="flat" cmpd="sng" algn="ctr">
-                      <a:solidFill>
-                        <a:srgbClr val="B7C4CC"/>
-                      </a:solidFill>
-                      <a:prstDash val="solid"/>
-                      <a:round/>
-                      <a:headEnd type="none" w="med" len="med"/>
-                      <a:tailEnd type="none" w="med" len="med"/>
-                    </a:lnB>
-                    <a:solidFill>
-                      <a:srgbClr val="075056"/>
-                    </a:solidFill>
-                  </a:tcPr>
-                </a:tc>
-                <a:extLst>
-                  <a:ext uri="{0D108BD9-81ED-4DB2-BD59-A6C34878D82A}">
-                    <a16:rowId xmlns:a16="http://schemas.microsoft.com/office/drawing/2014/main" val="10000"/>
-                  </a:ext>
-                </a:extLst>
-              </a:tr>
-              <a:tr h="566928">
-                <a:tc>
-                  <a:txBody>
-                    <a:bodyPr/>
-                    <a:lstStyle/>
-                    <a:p>
-                      <a:pPr marL="0" indent="0">
-                        <a:buNone/>
-                      </a:pPr>
-                      <a:r>
-                        <a:rPr lang="en-US" sz="1100" b="1">
-                          <a:solidFill>
-                            <a:srgbClr val="024879"/>
-                          </a:solidFill>
-                          <a:latin typeface="Calibri" pitchFamily="34" charset="0"/>
-                          <a:ea typeface="Calibri" pitchFamily="34" charset="-122"/>
-                          <a:cs typeface="Calibri" pitchFamily="34" charset="-120"/>
-                        </a:rPr>
-                        <a:t>Spec-Driven Development</a:t>
-                      </a:r>
-                      <a:endParaRPr lang="en-US" sz="1100">
-                        <a:latin typeface="Calibri" charset="0"/>
-                        <a:ea typeface="Calibri" charset="0"/>
-                        <a:cs typeface="Calibri" charset="0"/>
-                      </a:endParaRPr>
-                    </a:p>
-                  </a:txBody>
-                  <a:tcPr anchor="ctr">
-                    <a:lnL w="6350" cap="flat" cmpd="sng" algn="ctr">
-                      <a:solidFill>
-                        <a:srgbClr val="B7C4CC"/>
-                      </a:solidFill>
-                      <a:prstDash val="solid"/>
-                      <a:round/>
-                      <a:headEnd type="none" w="med" len="med"/>
-                      <a:tailEnd type="none" w="med" len="med"/>
-                    </a:lnL>
-                    <a:lnR w="6350" cap="flat" cmpd="sng" algn="ctr">
-                      <a:solidFill>
-                        <a:srgbClr val="B7C4CC"/>
-                      </a:solidFill>
-                      <a:prstDash val="solid"/>
-                      <a:round/>
-                      <a:headEnd type="none" w="med" len="med"/>
-                      <a:tailEnd type="none" w="med" len="med"/>
-                    </a:lnR>
-                    <a:lnT w="6350" cap="flat" cmpd="sng" algn="ctr">
-                      <a:solidFill>
-                        <a:srgbClr val="B7C4CC"/>
-                      </a:solidFill>
-                      <a:prstDash val="solid"/>
-                      <a:round/>
-                      <a:headEnd type="none" w="med" len="med"/>
-                      <a:tailEnd type="none" w="med" len="med"/>
-                    </a:lnT>
-                    <a:lnB w="6350" cap="flat" cmpd="sng" algn="ctr">
-                      <a:solidFill>
-                        <a:srgbClr val="B7C4CC"/>
-                      </a:solidFill>
-                      <a:prstDash val="solid"/>
-                      <a:round/>
-                      <a:headEnd type="none" w="med" len="med"/>
-                      <a:tailEnd type="none" w="med" len="med"/>
-                    </a:lnB>
-                    <a:solidFill>
-                      <a:srgbClr val="DFE7ED"/>
-                    </a:solidFill>
-                  </a:tcPr>
-                </a:tc>
-                <a:tc>
-                  <a:txBody>
-                    <a:bodyPr/>
-                    <a:lstStyle/>
-                    <a:p>
-                      <a:pPr marL="0" indent="0">
-                        <a:buNone/>
-                      </a:pPr>
-                      <a:r>
-                        <a:rPr lang="en-US" sz="1100">
-                          <a:solidFill>
-                            <a:srgbClr val="1B2227"/>
-                          </a:solidFill>
-                          <a:latin typeface="Calibri" pitchFamily="34" charset="0"/>
-                          <a:ea typeface="Calibri" pitchFamily="34" charset="-122"/>
-                          <a:cs typeface="Calibri" pitchFamily="34" charset="-120"/>
-                        </a:rPr>
-                        <a:t>Spec discipline governs agent behaviour and hand-offs, not just a single file.</a:t>
-                      </a:r>
-                      <a:endParaRPr lang="en-US" sz="1100">
-                        <a:latin typeface="Calibri" charset="0"/>
-                        <a:ea typeface="Calibri" charset="0"/>
-                        <a:cs typeface="Calibri" charset="0"/>
-                      </a:endParaRPr>
-                    </a:p>
-                  </a:txBody>
-                  <a:tcPr anchor="ctr">
-                    <a:lnL w="6350" cap="flat" cmpd="sng" algn="ctr">
-                      <a:solidFill>
-                        <a:srgbClr val="B7C4CC"/>
-                      </a:solidFill>
-                      <a:prstDash val="solid"/>
-                      <a:round/>
-                      <a:headEnd type="none" w="med" len="med"/>
-                      <a:tailEnd type="none" w="med" len="med"/>
-                    </a:lnL>
-                    <a:lnR w="6350" cap="flat" cmpd="sng" algn="ctr">
-                      <a:solidFill>
-                        <a:srgbClr val="B7C4CC"/>
-                      </a:solidFill>
-                      <a:prstDash val="solid"/>
-                      <a:round/>
-                      <a:headEnd type="none" w="med" len="med"/>
-                      <a:tailEnd type="none" w="med" len="med"/>
-                    </a:lnR>
-                    <a:lnT w="6350" cap="flat" cmpd="sng" algn="ctr">
-                      <a:solidFill>
-                        <a:srgbClr val="B7C4CC"/>
-                      </a:solidFill>
-                      <a:prstDash val="solid"/>
-                      <a:round/>
-                      <a:headEnd type="none" w="med" len="med"/>
-                      <a:tailEnd type="none" w="med" len="med"/>
-                    </a:lnT>
-                    <a:lnB w="6350" cap="flat" cmpd="sng" algn="ctr">
-                      <a:solidFill>
-                        <a:srgbClr val="B7C4CC"/>
-                      </a:solidFill>
-                      <a:prstDash val="solid"/>
-                      <a:round/>
-                      <a:headEnd type="none" w="med" len="med"/>
-                      <a:tailEnd type="none" w="med" len="med"/>
-                    </a:lnB>
-                    <a:solidFill>
-                      <a:srgbClr val="DFE7ED"/>
-                    </a:solidFill>
-                  </a:tcPr>
-                </a:tc>
-                <a:tc>
-                  <a:txBody>
-                    <a:bodyPr/>
-                    <a:lstStyle/>
-                    <a:p>
-                      <a:pPr marL="0" indent="0" algn="ctr">
-                        <a:buNone/>
-                      </a:pPr>
-                      <a:r>
-                        <a:rPr lang="en-US" sz="1100" b="1">
-                          <a:solidFill>
-                            <a:srgbClr val="1B2227"/>
-                          </a:solidFill>
-                          <a:latin typeface="Calibri" pitchFamily="34" charset="0"/>
-                          <a:ea typeface="Calibri" pitchFamily="34" charset="-122"/>
-                          <a:cs typeface="Calibri" pitchFamily="34" charset="-120"/>
-                        </a:rPr>
-                        <a:t>30</a:t>
-                      </a:r>
-                      <a:endParaRPr lang="en-US" sz="1100">
-                        <a:latin typeface="Calibri" charset="0"/>
-                        <a:ea typeface="Calibri" charset="0"/>
-                        <a:cs typeface="Calibri" charset="0"/>
-                      </a:endParaRPr>
-                    </a:p>
-                  </a:txBody>
-                  <a:tcPr anchor="ctr">
-                    <a:lnL w="6350" cap="flat" cmpd="sng" algn="ctr">
-                      <a:solidFill>
-                        <a:srgbClr val="B7C4CC"/>
-                      </a:solidFill>
-                      <a:prstDash val="solid"/>
-                      <a:round/>
-                      <a:headEnd type="none" w="med" len="med"/>
-                      <a:tailEnd type="none" w="med" len="med"/>
-                    </a:lnL>
-                    <a:lnR w="6350" cap="flat" cmpd="sng" algn="ctr">
-                      <a:solidFill>
-                        <a:srgbClr val="B7C4CC"/>
-                      </a:solidFill>
-                      <a:prstDash val="solid"/>
-                      <a:round/>
-                      <a:headEnd type="none" w="med" len="med"/>
-                      <a:tailEnd type="none" w="med" len="med"/>
-                    </a:lnR>
-                    <a:lnT w="6350" cap="flat" cmpd="sng" algn="ctr">
-                      <a:solidFill>
-                        <a:srgbClr val="B7C4CC"/>
-                      </a:solidFill>
-                      <a:prstDash val="solid"/>
-                      <a:round/>
-                      <a:headEnd type="none" w="med" len="med"/>
-                      <a:tailEnd type="none" w="med" len="med"/>
-                    </a:lnT>
-                    <a:lnB w="6350" cap="flat" cmpd="sng" algn="ctr">
-                      <a:solidFill>
-                        <a:srgbClr val="B7C4CC"/>
-                      </a:solidFill>
-                      <a:prstDash val="solid"/>
-                      <a:round/>
-                      <a:headEnd type="none" w="med" len="med"/>
-                      <a:tailEnd type="none" w="med" len="med"/>
-                    </a:lnB>
-                    <a:solidFill>
-                      <a:srgbClr val="DFE7ED"/>
-                    </a:solidFill>
-                  </a:tcPr>
-                </a:tc>
-                <a:extLst>
-                  <a:ext uri="{0D108BD9-81ED-4DB2-BD59-A6C34878D82A}">
-                    <a16:rowId xmlns:a16="http://schemas.microsoft.com/office/drawing/2014/main" val="10001"/>
-                  </a:ext>
-                </a:extLst>
-              </a:tr>
-              <a:tr h="566928">
-                <a:tc>
-                  <a:txBody>
-                    <a:bodyPr/>
-                    <a:lstStyle/>
-                    <a:p>
-                      <a:pPr marL="0" indent="0">
-                        <a:buNone/>
-                      </a:pPr>
-                      <a:r>
-                        <a:rPr lang="en-US" sz="1100" b="1">
-                          <a:solidFill>
-                            <a:srgbClr val="024879"/>
-                          </a:solidFill>
-                          <a:latin typeface="Calibri" pitchFamily="34" charset="0"/>
-                          <a:ea typeface="Calibri" pitchFamily="34" charset="-122"/>
-                          <a:cs typeface="Calibri" pitchFamily="34" charset="-120"/>
-                        </a:rPr>
-                        <a:t>AI-Powered Development</a:t>
-                      </a:r>
-                      <a:endParaRPr lang="en-US" sz="1100">
-                        <a:latin typeface="Calibri" charset="0"/>
-                        <a:ea typeface="Calibri" charset="0"/>
-                        <a:cs typeface="Calibri" charset="0"/>
-                      </a:endParaRPr>
-                    </a:p>
-                  </a:txBody>
-                  <a:tcPr anchor="ctr">
-                    <a:lnL w="6350" cap="flat" cmpd="sng" algn="ctr">
-                      <a:solidFill>
-                        <a:srgbClr val="B7C4CC"/>
-                      </a:solidFill>
-                      <a:prstDash val="solid"/>
-                      <a:round/>
-                      <a:headEnd type="none" w="med" len="med"/>
-                      <a:tailEnd type="none" w="med" len="med"/>
-                    </a:lnL>
-                    <a:lnR w="6350" cap="flat" cmpd="sng" algn="ctr">
-                      <a:solidFill>
-                        <a:srgbClr val="B7C4CC"/>
-                      </a:solidFill>
-                      <a:prstDash val="solid"/>
-                      <a:round/>
-                      <a:headEnd type="none" w="med" len="med"/>
-                      <a:tailEnd type="none" w="med" len="med"/>
-                    </a:lnR>
-                    <a:lnT w="6350" cap="flat" cmpd="sng" algn="ctr">
-                      <a:solidFill>
-                        <a:srgbClr val="B7C4CC"/>
-                      </a:solidFill>
-                      <a:prstDash val="solid"/>
-                      <a:round/>
-                      <a:headEnd type="none" w="med" len="med"/>
-                      <a:tailEnd type="none" w="med" len="med"/>
-                    </a:lnT>
-                    <a:lnB w="6350" cap="flat" cmpd="sng" algn="ctr">
-                      <a:solidFill>
-                        <a:srgbClr val="B7C4CC"/>
-                      </a:solidFill>
-                      <a:prstDash val="solid"/>
-                      <a:round/>
-                      <a:headEnd type="none" w="med" len="med"/>
-                      <a:tailEnd type="none" w="med" len="med"/>
-                    </a:lnB>
-                    <a:solidFill>
-                      <a:srgbClr val="FFFFFF"/>
-                    </a:solidFill>
-                  </a:tcPr>
-                </a:tc>
-                <a:tc>
-                  <a:txBody>
-                    <a:bodyPr/>
-                    <a:lstStyle/>
-                    <a:p>
-                      <a:pPr marL="0" indent="0">
-                        <a:buNone/>
-                      </a:pPr>
-                      <a:r>
-                        <a:rPr lang="en-US" sz="1100">
-                          <a:solidFill>
-                            <a:srgbClr val="1B2227"/>
-                          </a:solidFill>
-                          <a:latin typeface="Calibri" pitchFamily="34" charset="0"/>
-                          <a:ea typeface="Calibri" pitchFamily="34" charset="-122"/>
-                          <a:cs typeface="Calibri" pitchFamily="34" charset="-120"/>
-                        </a:rPr>
-                        <a:t>Advanced Claude Code / Copilot (agent modes, CLI, skills) delivering working software.</a:t>
-                      </a:r>
-                      <a:endParaRPr lang="en-US" sz="1100">
-                        <a:latin typeface="Calibri" charset="0"/>
-                        <a:ea typeface="Calibri" charset="0"/>
-                        <a:cs typeface="Calibri" charset="0"/>
-                      </a:endParaRPr>
-                    </a:p>
-                  </a:txBody>
-                  <a:tcPr anchor="ctr">
-                    <a:lnL w="6350" cap="flat" cmpd="sng" algn="ctr">
-                      <a:solidFill>
-                        <a:srgbClr val="B7C4CC"/>
-                      </a:solidFill>
-                      <a:prstDash val="solid"/>
-                      <a:round/>
-                      <a:headEnd type="none" w="med" len="med"/>
-                      <a:tailEnd type="none" w="med" len="med"/>
-                    </a:lnL>
-                    <a:lnR w="6350" cap="flat" cmpd="sng" algn="ctr">
-                      <a:solidFill>
-                        <a:srgbClr val="B7C4CC"/>
-                      </a:solidFill>
-                      <a:prstDash val="solid"/>
-                      <a:round/>
-                      <a:headEnd type="none" w="med" len="med"/>
-                      <a:tailEnd type="none" w="med" len="med"/>
-                    </a:lnR>
-                    <a:lnT w="6350" cap="flat" cmpd="sng" algn="ctr">
-                      <a:solidFill>
-                        <a:srgbClr val="B7C4CC"/>
-                      </a:solidFill>
-                      <a:prstDash val="solid"/>
-                      <a:round/>
-                      <a:headEnd type="none" w="med" len="med"/>
-                      <a:tailEnd type="none" w="med" len="med"/>
-                    </a:lnT>
-                    <a:lnB w="6350" cap="flat" cmpd="sng" algn="ctr">
-                      <a:solidFill>
-                        <a:srgbClr val="B7C4CC"/>
-                      </a:solidFill>
-                      <a:prstDash val="solid"/>
-                      <a:round/>
-                      <a:headEnd type="none" w="med" len="med"/>
-                      <a:tailEnd type="none" w="med" len="med"/>
-                    </a:lnB>
-                    <a:solidFill>
-                      <a:srgbClr val="FFFFFF"/>
-                    </a:solidFill>
-                  </a:tcPr>
-                </a:tc>
-                <a:tc>
-                  <a:txBody>
-                    <a:bodyPr/>
-                    <a:lstStyle/>
-                    <a:p>
-                      <a:pPr marL="0" indent="0" algn="ctr">
-                        <a:buNone/>
-                      </a:pPr>
-                      <a:r>
-                        <a:rPr lang="en-US" sz="1100" b="1">
-                          <a:solidFill>
-                            <a:srgbClr val="1B2227"/>
-                          </a:solidFill>
-                          <a:latin typeface="Calibri" pitchFamily="34" charset="0"/>
-                          <a:ea typeface="Calibri" pitchFamily="34" charset="-122"/>
-                          <a:cs typeface="Calibri" pitchFamily="34" charset="-120"/>
-                        </a:rPr>
-                        <a:t>30</a:t>
-                      </a:r>
-                      <a:endParaRPr lang="en-US" sz="1100">
-                        <a:latin typeface="Calibri" charset="0"/>
-                        <a:ea typeface="Calibri" charset="0"/>
-                        <a:cs typeface="Calibri" charset="0"/>
-                      </a:endParaRPr>
-                    </a:p>
-                  </a:txBody>
-                  <a:tcPr anchor="ctr">
-                    <a:lnL w="6350" cap="flat" cmpd="sng" algn="ctr">
-                      <a:solidFill>
-                        <a:srgbClr val="B7C4CC"/>
-                      </a:solidFill>
-                      <a:prstDash val="solid"/>
-                      <a:round/>
-                      <a:headEnd type="none" w="med" len="med"/>
-                      <a:tailEnd type="none" w="med" len="med"/>
-                    </a:lnL>
-                    <a:lnR w="6350" cap="flat" cmpd="sng" algn="ctr">
-                      <a:solidFill>
-                        <a:srgbClr val="B7C4CC"/>
-                      </a:solidFill>
-                      <a:prstDash val="solid"/>
-                      <a:round/>
-                      <a:headEnd type="none" w="med" len="med"/>
-                      <a:tailEnd type="none" w="med" len="med"/>
-                    </a:lnR>
-                    <a:lnT w="6350" cap="flat" cmpd="sng" algn="ctr">
-                      <a:solidFill>
-                        <a:srgbClr val="B7C4CC"/>
-                      </a:solidFill>
-                      <a:prstDash val="solid"/>
-                      <a:round/>
-                      <a:headEnd type="none" w="med" len="med"/>
-                      <a:tailEnd type="none" w="med" len="med"/>
-                    </a:lnT>
-                    <a:lnB w="6350" cap="flat" cmpd="sng" algn="ctr">
-                      <a:solidFill>
-                        <a:srgbClr val="B7C4CC"/>
-                      </a:solidFill>
-                      <a:prstDash val="solid"/>
-                      <a:round/>
-                      <a:headEnd type="none" w="med" len="med"/>
-                      <a:tailEnd type="none" w="med" len="med"/>
-                    </a:lnB>
-                    <a:solidFill>
-                      <a:srgbClr val="FFFFFF"/>
-                    </a:solidFill>
-                  </a:tcPr>
-                </a:tc>
-                <a:extLst>
-                  <a:ext uri="{0D108BD9-81ED-4DB2-BD59-A6C34878D82A}">
-                    <a16:rowId xmlns:a16="http://schemas.microsoft.com/office/drawing/2014/main" val="10002"/>
-                  </a:ext>
-                </a:extLst>
-              </a:tr>
-              <a:tr h="566928">
-                <a:tc>
-                  <a:txBody>
-                    <a:bodyPr/>
-                    <a:lstStyle/>
-                    <a:p>
-                      <a:pPr marL="0" indent="0">
-                        <a:buNone/>
-                      </a:pPr>
-                      <a:r>
-                        <a:rPr lang="en-US" sz="1100" b="1">
-                          <a:solidFill>
-                            <a:srgbClr val="024879"/>
-                          </a:solidFill>
-                          <a:latin typeface="Calibri" pitchFamily="34" charset="0"/>
-                          <a:ea typeface="Calibri" pitchFamily="34" charset="-122"/>
-                          <a:cs typeface="Calibri" pitchFamily="34" charset="-120"/>
-                        </a:rPr>
-                        <a:t>LLM Evaluation &amp; Interpretability</a:t>
-                      </a:r>
-                      <a:endParaRPr lang="en-US" sz="1100">
-                        <a:latin typeface="Calibri" charset="0"/>
-                        <a:ea typeface="Calibri" charset="0"/>
-                        <a:cs typeface="Calibri" charset="0"/>
-                      </a:endParaRPr>
-                    </a:p>
-                  </a:txBody>
-                  <a:tcPr anchor="ctr">
-                    <a:lnL w="6350" cap="flat" cmpd="sng" algn="ctr">
-                      <a:solidFill>
-                        <a:srgbClr val="B7C4CC"/>
-                      </a:solidFill>
-                      <a:prstDash val="solid"/>
-                      <a:round/>
-                      <a:headEnd type="none" w="med" len="med"/>
-                      <a:tailEnd type="none" w="med" len="med"/>
-                    </a:lnL>
-                    <a:lnR w="6350" cap="flat" cmpd="sng" algn="ctr">
-                      <a:solidFill>
-                        <a:srgbClr val="B7C4CC"/>
-                      </a:solidFill>
-                      <a:prstDash val="solid"/>
-                      <a:round/>
-                      <a:headEnd type="none" w="med" len="med"/>
-                      <a:tailEnd type="none" w="med" len="med"/>
-                    </a:lnR>
-                    <a:lnT w="6350" cap="flat" cmpd="sng" algn="ctr">
-                      <a:solidFill>
-                        <a:srgbClr val="B7C4CC"/>
-                      </a:solidFill>
-                      <a:prstDash val="solid"/>
-                      <a:round/>
-                      <a:headEnd type="none" w="med" len="med"/>
-                      <a:tailEnd type="none" w="med" len="med"/>
-                    </a:lnT>
-                    <a:lnB w="6350" cap="flat" cmpd="sng" algn="ctr">
-                      <a:solidFill>
-                        <a:srgbClr val="B7C4CC"/>
-                      </a:solidFill>
-                      <a:prstDash val="solid"/>
-                      <a:round/>
-                      <a:headEnd type="none" w="med" len="med"/>
-                      <a:tailEnd type="none" w="med" len="med"/>
-                    </a:lnB>
-                    <a:solidFill>
-                      <a:srgbClr val="DFE7ED"/>
-                    </a:solidFill>
-                  </a:tcPr>
-                </a:tc>
-                <a:tc>
-                  <a:txBody>
-                    <a:bodyPr/>
-                    <a:lstStyle/>
-                    <a:p>
-                      <a:pPr marL="0" indent="0">
-                        <a:buNone/>
-                      </a:pPr>
-                      <a:r>
-                        <a:rPr lang="en-US" sz="1100">
-                          <a:solidFill>
-                            <a:srgbClr val="1B2227"/>
-                          </a:solidFill>
-                          <a:latin typeface="Calibri" pitchFamily="34" charset="0"/>
-                          <a:ea typeface="Calibri" pitchFamily="34" charset="-122"/>
-                          <a:cs typeface="Calibri" pitchFamily="34" charset="-120"/>
-                        </a:rPr>
-                        <a:t>Objective evaluation (LLM-as-judge, scored comparisons); data-grounded decisions.</a:t>
-                      </a:r>
-                      <a:endParaRPr lang="en-US" sz="1100">
-                        <a:latin typeface="Calibri" charset="0"/>
-                        <a:ea typeface="Calibri" charset="0"/>
-                        <a:cs typeface="Calibri" charset="0"/>
-                      </a:endParaRPr>
-                    </a:p>
-                  </a:txBody>
-                  <a:tcPr anchor="ctr">
-                    <a:lnL w="6350" cap="flat" cmpd="sng" algn="ctr">
-                      <a:solidFill>
-                        <a:srgbClr val="B7C4CC"/>
-                      </a:solidFill>
-                      <a:prstDash val="solid"/>
-                      <a:round/>
-                      <a:headEnd type="none" w="med" len="med"/>
-                      <a:tailEnd type="none" w="med" len="med"/>
-                    </a:lnL>
-                    <a:lnR w="6350" cap="flat" cmpd="sng" algn="ctr">
-                      <a:solidFill>
-                        <a:srgbClr val="B7C4CC"/>
-                      </a:solidFill>
-                      <a:prstDash val="solid"/>
-                      <a:round/>
-                      <a:headEnd type="none" w="med" len="med"/>
-                      <a:tailEnd type="none" w="med" len="med"/>
-                    </a:lnR>
-                    <a:lnT w="6350" cap="flat" cmpd="sng" algn="ctr">
-                      <a:solidFill>
-                        <a:srgbClr val="B7C4CC"/>
-                      </a:solidFill>
-                      <a:prstDash val="solid"/>
-                      <a:round/>
-                      <a:headEnd type="none" w="med" len="med"/>
-                      <a:tailEnd type="none" w="med" len="med"/>
-                    </a:lnT>
-                    <a:lnB w="6350" cap="flat" cmpd="sng" algn="ctr">
-                      <a:solidFill>
-                        <a:srgbClr val="B7C4CC"/>
-                      </a:solidFill>
-                      <a:prstDash val="solid"/>
-                      <a:round/>
-                      <a:headEnd type="none" w="med" len="med"/>
-                      <a:tailEnd type="none" w="med" len="med"/>
-                    </a:lnB>
-                    <a:solidFill>
-                      <a:srgbClr val="DFE7ED"/>
-                    </a:solidFill>
-                  </a:tcPr>
-                </a:tc>
-                <a:tc>
-                  <a:txBody>
-                    <a:bodyPr/>
-                    <a:lstStyle/>
-                    <a:p>
-                      <a:pPr marL="0" indent="0" algn="ctr">
-                        <a:buNone/>
-                      </a:pPr>
-                      <a:r>
-                        <a:rPr lang="en-US" sz="1100" b="1">
-                          <a:solidFill>
-                            <a:srgbClr val="1B2227"/>
-                          </a:solidFill>
-                          <a:latin typeface="Calibri" pitchFamily="34" charset="0"/>
-                          <a:ea typeface="Calibri" pitchFamily="34" charset="-122"/>
-                          <a:cs typeface="Calibri" pitchFamily="34" charset="-120"/>
-                        </a:rPr>
-                        <a:t>30</a:t>
-                      </a:r>
-                      <a:endParaRPr lang="en-US" sz="1100">
-                        <a:latin typeface="Calibri" charset="0"/>
-                        <a:ea typeface="Calibri" charset="0"/>
-                        <a:cs typeface="Calibri" charset="0"/>
-                      </a:endParaRPr>
-                    </a:p>
-                  </a:txBody>
-                  <a:tcPr anchor="ctr">
-                    <a:lnL w="6350" cap="flat" cmpd="sng" algn="ctr">
-                      <a:solidFill>
-                        <a:srgbClr val="B7C4CC"/>
-                      </a:solidFill>
-                      <a:prstDash val="solid"/>
-                      <a:round/>
-                      <a:headEnd type="none" w="med" len="med"/>
-                      <a:tailEnd type="none" w="med" len="med"/>
-                    </a:lnL>
-                    <a:lnR w="6350" cap="flat" cmpd="sng" algn="ctr">
-                      <a:solidFill>
-                        <a:srgbClr val="B7C4CC"/>
-                      </a:solidFill>
-                      <a:prstDash val="solid"/>
-                      <a:round/>
-                      <a:headEnd type="none" w="med" len="med"/>
-                      <a:tailEnd type="none" w="med" len="med"/>
-                    </a:lnR>
-                    <a:lnT w="6350" cap="flat" cmpd="sng" algn="ctr">
-                      <a:solidFill>
-                        <a:srgbClr val="B7C4CC"/>
-                      </a:solidFill>
-                      <a:prstDash val="solid"/>
-                      <a:round/>
-                      <a:headEnd type="none" w="med" len="med"/>
-                      <a:tailEnd type="none" w="med" len="med"/>
-                    </a:lnT>
-                    <a:lnB w="6350" cap="flat" cmpd="sng" algn="ctr">
-                      <a:solidFill>
-                        <a:srgbClr val="B7C4CC"/>
-                      </a:solidFill>
-                      <a:prstDash val="solid"/>
-                      <a:round/>
-                      <a:headEnd type="none" w="med" len="med"/>
-                      <a:tailEnd type="none" w="med" len="med"/>
-                    </a:lnB>
-                    <a:solidFill>
-                      <a:srgbClr val="DFE7ED"/>
-                    </a:solidFill>
-                  </a:tcPr>
-                </a:tc>
-                <a:extLst>
-                  <a:ext uri="{0D108BD9-81ED-4DB2-BD59-A6C34878D82A}">
-                    <a16:rowId xmlns:a16="http://schemas.microsoft.com/office/drawing/2014/main" val="10003"/>
-                  </a:ext>
-                </a:extLst>
-              </a:tr>
-              <a:tr h="566928">
-                <a:tc>
-                  <a:txBody>
-                    <a:bodyPr/>
-                    <a:lstStyle/>
-                    <a:p>
-                      <a:pPr marL="0" indent="0">
-                        <a:buNone/>
-                      </a:pPr>
-                      <a:r>
-                        <a:rPr lang="en-US" sz="1100" b="1">
-                          <a:solidFill>
-                            <a:srgbClr val="024879"/>
-                          </a:solidFill>
-                          <a:latin typeface="Calibri" pitchFamily="34" charset="0"/>
-                          <a:ea typeface="Calibri" pitchFamily="34" charset="-122"/>
-                          <a:cs typeface="Calibri" pitchFamily="34" charset="-120"/>
-                        </a:rPr>
-                        <a:t>Agent Design, Orchestration &amp; Ops</a:t>
-                      </a:r>
-                      <a:endParaRPr lang="en-US" sz="1100">
-                        <a:latin typeface="Calibri" charset="0"/>
-                        <a:ea typeface="Calibri" charset="0"/>
-                        <a:cs typeface="Calibri" charset="0"/>
-                      </a:endParaRPr>
-                    </a:p>
-                  </a:txBody>
-                  <a:tcPr anchor="ctr">
-                    <a:lnL w="6350" cap="flat" cmpd="sng" algn="ctr">
-                      <a:solidFill>
-                        <a:srgbClr val="B7C4CC"/>
-                      </a:solidFill>
-                      <a:prstDash val="solid"/>
-                      <a:round/>
-                      <a:headEnd type="none" w="med" len="med"/>
-                      <a:tailEnd type="none" w="med" len="med"/>
-                    </a:lnL>
-                    <a:lnR w="6350" cap="flat" cmpd="sng" algn="ctr">
-                      <a:solidFill>
-                        <a:srgbClr val="B7C4CC"/>
-                      </a:solidFill>
-                      <a:prstDash val="solid"/>
-                      <a:round/>
-                      <a:headEnd type="none" w="med" len="med"/>
-                      <a:tailEnd type="none" w="med" len="med"/>
-                    </a:lnR>
-                    <a:lnT w="6350" cap="flat" cmpd="sng" algn="ctr">
-                      <a:solidFill>
-                        <a:srgbClr val="B7C4CC"/>
-                      </a:solidFill>
-                      <a:prstDash val="solid"/>
-                      <a:round/>
-                      <a:headEnd type="none" w="med" len="med"/>
-                      <a:tailEnd type="none" w="med" len="med"/>
-                    </a:lnT>
-                    <a:lnB w="6350" cap="flat" cmpd="sng" algn="ctr">
-                      <a:solidFill>
-                        <a:srgbClr val="B7C4CC"/>
-                      </a:solidFill>
-                      <a:prstDash val="solid"/>
-                      <a:round/>
-                      <a:headEnd type="none" w="med" len="med"/>
-                      <a:tailEnd type="none" w="med" len="med"/>
-                    </a:lnB>
-                    <a:solidFill>
-                      <a:srgbClr val="FFFFFF"/>
-                    </a:solidFill>
-                  </a:tcPr>
-                </a:tc>
-                <a:tc>
-                  <a:txBody>
-                    <a:bodyPr/>
-                    <a:lstStyle/>
-                    <a:p>
-                      <a:pPr marL="0" indent="0">
-                        <a:buNone/>
-                      </a:pPr>
-                      <a:r>
-                        <a:rPr lang="en-US" sz="1100">
-                          <a:solidFill>
-                            <a:srgbClr val="1B2227"/>
-                          </a:solidFill>
-                          <a:latin typeface="Calibri" pitchFamily="34" charset="0"/>
-                          <a:ea typeface="Calibri" pitchFamily="34" charset="-122"/>
-                          <a:cs typeface="Calibri" pitchFamily="34" charset="-120"/>
-                        </a:rPr>
-                        <a:t>Multi-agent / multi-step orchestration with failure handling, recovery, observability.</a:t>
-                      </a:r>
-                      <a:endParaRPr lang="en-US" sz="1100">
-                        <a:latin typeface="Calibri" charset="0"/>
-                        <a:ea typeface="Calibri" charset="0"/>
-                        <a:cs typeface="Calibri" charset="0"/>
-                      </a:endParaRPr>
-                    </a:p>
-                  </a:txBody>
-                  <a:tcPr anchor="ctr">
-                    <a:lnL w="6350" cap="flat" cmpd="sng" algn="ctr">
-                      <a:solidFill>
-                        <a:srgbClr val="B7C4CC"/>
-                      </a:solidFill>
-                      <a:prstDash val="solid"/>
-                      <a:round/>
-                      <a:headEnd type="none" w="med" len="med"/>
-                      <a:tailEnd type="none" w="med" len="med"/>
-                    </a:lnL>
-                    <a:lnR w="6350" cap="flat" cmpd="sng" algn="ctr">
-                      <a:solidFill>
-                        <a:srgbClr val="B7C4CC"/>
-                      </a:solidFill>
-                      <a:prstDash val="solid"/>
-                      <a:round/>
-                      <a:headEnd type="none" w="med" len="med"/>
-                      <a:tailEnd type="none" w="med" len="med"/>
-                    </a:lnR>
-                    <a:lnT w="6350" cap="flat" cmpd="sng" algn="ctr">
-                      <a:solidFill>
-                        <a:srgbClr val="B7C4CC"/>
-                      </a:solidFill>
-                      <a:prstDash val="solid"/>
-                      <a:round/>
-                      <a:headEnd type="none" w="med" len="med"/>
-                      <a:tailEnd type="none" w="med" len="med"/>
-                    </a:lnT>
-                    <a:lnB w="6350" cap="flat" cmpd="sng" algn="ctr">
-                      <a:solidFill>
-                        <a:srgbClr val="B7C4CC"/>
-                      </a:solidFill>
-                      <a:prstDash val="solid"/>
-                      <a:round/>
-                      <a:headEnd type="none" w="med" len="med"/>
-                      <a:tailEnd type="none" w="med" len="med"/>
-                    </a:lnB>
-                    <a:solidFill>
-                      <a:srgbClr val="FFFFFF"/>
-                    </a:solidFill>
-                  </a:tcPr>
-                </a:tc>
-                <a:tc>
-                  <a:txBody>
-                    <a:bodyPr/>
-                    <a:lstStyle/>
-                    <a:p>
-                      <a:pPr marL="0" indent="0" algn="ctr">
-                        <a:buNone/>
-                      </a:pPr>
-                      <a:r>
-                        <a:rPr lang="en-US" sz="1100" b="1">
-                          <a:solidFill>
-                            <a:srgbClr val="1B2227"/>
-                          </a:solidFill>
-                          <a:latin typeface="Calibri" pitchFamily="34" charset="0"/>
-                          <a:ea typeface="Calibri" pitchFamily="34" charset="-122"/>
-                          <a:cs typeface="Calibri" pitchFamily="34" charset="-120"/>
-                        </a:rPr>
-                        <a:t>30</a:t>
-                      </a:r>
-                      <a:endParaRPr lang="en-US" sz="1100">
-                        <a:latin typeface="Calibri" charset="0"/>
-                        <a:ea typeface="Calibri" charset="0"/>
-                        <a:cs typeface="Calibri" charset="0"/>
-                      </a:endParaRPr>
-                    </a:p>
-                  </a:txBody>
-                  <a:tcPr anchor="ctr">
-                    <a:lnL w="6350" cap="flat" cmpd="sng" algn="ctr">
-                      <a:solidFill>
-                        <a:srgbClr val="B7C4CC"/>
-                      </a:solidFill>
-                      <a:prstDash val="solid"/>
-                      <a:round/>
-                      <a:headEnd type="none" w="med" len="med"/>
-                      <a:tailEnd type="none" w="med" len="med"/>
-                    </a:lnL>
-                    <a:lnR w="6350" cap="flat" cmpd="sng" algn="ctr">
-                      <a:solidFill>
-                        <a:srgbClr val="B7C4CC"/>
-                      </a:solidFill>
-                      <a:prstDash val="solid"/>
-                      <a:round/>
-                      <a:headEnd type="none" w="med" len="med"/>
-                      <a:tailEnd type="none" w="med" len="med"/>
-                    </a:lnR>
-                    <a:lnT w="6350" cap="flat" cmpd="sng" algn="ctr">
-                      <a:solidFill>
-                        <a:srgbClr val="B7C4CC"/>
-                      </a:solidFill>
-                      <a:prstDash val="solid"/>
-                      <a:round/>
-                      <a:headEnd type="none" w="med" len="med"/>
-                      <a:tailEnd type="none" w="med" len="med"/>
-                    </a:lnT>
-                    <a:lnB w="6350" cap="flat" cmpd="sng" algn="ctr">
-                      <a:solidFill>
-                        <a:srgbClr val="B7C4CC"/>
-                      </a:solidFill>
-                      <a:prstDash val="solid"/>
-                      <a:round/>
-                      <a:headEnd type="none" w="med" len="med"/>
-                      <a:tailEnd type="none" w="med" len="med"/>
-                    </a:lnB>
-                    <a:solidFill>
-                      <a:srgbClr val="FFFFFF"/>
-                    </a:solidFill>
-                  </a:tcPr>
-                </a:tc>
-                <a:extLst>
-                  <a:ext uri="{0D108BD9-81ED-4DB2-BD59-A6C34878D82A}">
-                    <a16:rowId xmlns:a16="http://schemas.microsoft.com/office/drawing/2014/main" val="10004"/>
-                  </a:ext>
-                </a:extLst>
-              </a:tr>
-              <a:tr h="566928">
-                <a:tc>
-                  <a:txBody>
-                    <a:bodyPr/>
-                    <a:lstStyle/>
-                    <a:p>
-                      <a:pPr marL="0" indent="0">
-                        <a:buNone/>
-                      </a:pPr>
-                      <a:r>
-                        <a:rPr lang="en-US" sz="1100" b="1">
-                          <a:solidFill>
-                            <a:srgbClr val="024879"/>
-                          </a:solidFill>
-                          <a:latin typeface="Calibri" pitchFamily="34" charset="0"/>
-                          <a:ea typeface="Calibri" pitchFamily="34" charset="-122"/>
-                          <a:cs typeface="Calibri" pitchFamily="34" charset="-120"/>
-                        </a:rPr>
-                        <a:t>AI Tool Integration &amp; Extensibility</a:t>
-                      </a:r>
-                      <a:endParaRPr lang="en-US" sz="1100">
-                        <a:latin typeface="Calibri" charset="0"/>
-                        <a:ea typeface="Calibri" charset="0"/>
-                        <a:cs typeface="Calibri" charset="0"/>
-                      </a:endParaRPr>
-                    </a:p>
-                  </a:txBody>
-                  <a:tcPr anchor="ctr">
-                    <a:lnL w="6350" cap="flat" cmpd="sng" algn="ctr">
-                      <a:solidFill>
-                        <a:srgbClr val="B7C4CC"/>
-                      </a:solidFill>
-                      <a:prstDash val="solid"/>
-                      <a:round/>
-                      <a:headEnd type="none" w="med" len="med"/>
-                      <a:tailEnd type="none" w="med" len="med"/>
-                    </a:lnL>
-                    <a:lnR w="6350" cap="flat" cmpd="sng" algn="ctr">
-                      <a:solidFill>
-                        <a:srgbClr val="B7C4CC"/>
-                      </a:solidFill>
-                      <a:prstDash val="solid"/>
-                      <a:round/>
-                      <a:headEnd type="none" w="med" len="med"/>
-                      <a:tailEnd type="none" w="med" len="med"/>
-                    </a:lnR>
-                    <a:lnT w="6350" cap="flat" cmpd="sng" algn="ctr">
-                      <a:solidFill>
-                        <a:srgbClr val="B7C4CC"/>
-                      </a:solidFill>
-                      <a:prstDash val="solid"/>
-                      <a:round/>
-                      <a:headEnd type="none" w="med" len="med"/>
-                      <a:tailEnd type="none" w="med" len="med"/>
-                    </a:lnT>
-                    <a:lnB w="6350" cap="flat" cmpd="sng" algn="ctr">
-                      <a:solidFill>
-                        <a:srgbClr val="B7C4CC"/>
-                      </a:solidFill>
-                      <a:prstDash val="solid"/>
-                      <a:round/>
-                      <a:headEnd type="none" w="med" len="med"/>
-                      <a:tailEnd type="none" w="med" len="med"/>
-                    </a:lnB>
-                    <a:solidFill>
-                      <a:srgbClr val="DFE7ED"/>
-                    </a:solidFill>
-                  </a:tcPr>
-                </a:tc>
-                <a:tc>
-                  <a:txBody>
-                    <a:bodyPr/>
-                    <a:lstStyle/>
-                    <a:p>
-                      <a:pPr marL="0" indent="0">
-                        <a:buNone/>
-                      </a:pPr>
-                      <a:r>
-                        <a:rPr lang="en-US" sz="1100">
-                          <a:solidFill>
-                            <a:srgbClr val="1B2227"/>
-                          </a:solidFill>
-                          <a:latin typeface="Calibri" pitchFamily="34" charset="0"/>
-                          <a:ea typeface="Calibri" pitchFamily="34" charset="-122"/>
-                          <a:cs typeface="Calibri" pitchFamily="34" charset="-120"/>
-                        </a:rPr>
-                        <a:t>Extended agents via MCP servers, hooks, or custom skills/tools — secure and reusable.</a:t>
-                      </a:r>
-                      <a:endParaRPr lang="en-US" sz="1100">
-                        <a:latin typeface="Calibri" charset="0"/>
-                        <a:ea typeface="Calibri" charset="0"/>
-                        <a:cs typeface="Calibri" charset="0"/>
-                      </a:endParaRPr>
-                    </a:p>
-                  </a:txBody>
-                  <a:tcPr anchor="ctr">
-                    <a:lnL w="6350" cap="flat" cmpd="sng" algn="ctr">
-                      <a:solidFill>
-                        <a:srgbClr val="B7C4CC"/>
-                      </a:solidFill>
-                      <a:prstDash val="solid"/>
-                      <a:round/>
-                      <a:headEnd type="none" w="med" len="med"/>
-                      <a:tailEnd type="none" w="med" len="med"/>
-                    </a:lnL>
-                    <a:lnR w="6350" cap="flat" cmpd="sng" algn="ctr">
-                      <a:solidFill>
-                        <a:srgbClr val="B7C4CC"/>
-                      </a:solidFill>
-                      <a:prstDash val="solid"/>
-                      <a:round/>
-                      <a:headEnd type="none" w="med" len="med"/>
-                      <a:tailEnd type="none" w="med" len="med"/>
-                    </a:lnR>
-                    <a:lnT w="6350" cap="flat" cmpd="sng" algn="ctr">
-                      <a:solidFill>
-                        <a:srgbClr val="B7C4CC"/>
-                      </a:solidFill>
-                      <a:prstDash val="solid"/>
-                      <a:round/>
-                      <a:headEnd type="none" w="med" len="med"/>
-                      <a:tailEnd type="none" w="med" len="med"/>
-                    </a:lnT>
-                    <a:lnB w="6350" cap="flat" cmpd="sng" algn="ctr">
-                      <a:solidFill>
-                        <a:srgbClr val="B7C4CC"/>
-                      </a:solidFill>
-                      <a:prstDash val="solid"/>
-                      <a:round/>
-                      <a:headEnd type="none" w="med" len="med"/>
-                      <a:tailEnd type="none" w="med" len="med"/>
-                    </a:lnB>
-                    <a:solidFill>
-                      <a:srgbClr val="DFE7ED"/>
-                    </a:solidFill>
-                  </a:tcPr>
-                </a:tc>
-                <a:tc>
-                  <a:txBody>
-                    <a:bodyPr/>
-                    <a:lstStyle/>
-                    <a:p>
-                      <a:pPr marL="0" indent="0" algn="ctr">
-                        <a:buNone/>
-                      </a:pPr>
-                      <a:r>
-                        <a:rPr lang="en-US" sz="1100" b="1">
-                          <a:solidFill>
-                            <a:srgbClr val="1B2227"/>
-                          </a:solidFill>
-                          <a:latin typeface="Calibri" pitchFamily="34" charset="0"/>
-                          <a:ea typeface="Calibri" pitchFamily="34" charset="-122"/>
-                          <a:cs typeface="Calibri" pitchFamily="34" charset="-120"/>
-                        </a:rPr>
-                        <a:t>30</a:t>
-                      </a:r>
-                      <a:endParaRPr lang="en-US" sz="1100">
-                        <a:latin typeface="Calibri" charset="0"/>
-                        <a:ea typeface="Calibri" charset="0"/>
-                        <a:cs typeface="Calibri" charset="0"/>
-                      </a:endParaRPr>
-                    </a:p>
-                  </a:txBody>
-                  <a:tcPr anchor="ctr">
-                    <a:lnL w="6350" cap="flat" cmpd="sng" algn="ctr">
-                      <a:solidFill>
-                        <a:srgbClr val="B7C4CC"/>
-                      </a:solidFill>
-                      <a:prstDash val="solid"/>
-                      <a:round/>
-                      <a:headEnd type="none" w="med" len="med"/>
-                      <a:tailEnd type="none" w="med" len="med"/>
-                    </a:lnL>
-                    <a:lnR w="6350" cap="flat" cmpd="sng" algn="ctr">
-                      <a:solidFill>
-                        <a:srgbClr val="B7C4CC"/>
-                      </a:solidFill>
-                      <a:prstDash val="solid"/>
-                      <a:round/>
-                      <a:headEnd type="none" w="med" len="med"/>
-                      <a:tailEnd type="none" w="med" len="med"/>
-                    </a:lnR>
-                    <a:lnT w="6350" cap="flat" cmpd="sng" algn="ctr">
-                      <a:solidFill>
-                        <a:srgbClr val="B7C4CC"/>
-                      </a:solidFill>
-                      <a:prstDash val="solid"/>
-                      <a:round/>
-                      <a:headEnd type="none" w="med" len="med"/>
-                      <a:tailEnd type="none" w="med" len="med"/>
-                    </a:lnT>
-                    <a:lnB w="6350" cap="flat" cmpd="sng" algn="ctr">
-                      <a:solidFill>
-                        <a:srgbClr val="B7C4CC"/>
-                      </a:solidFill>
-                      <a:prstDash val="solid"/>
-                      <a:round/>
-                      <a:headEnd type="none" w="med" len="med"/>
-                      <a:tailEnd type="none" w="med" len="med"/>
-                    </a:lnB>
-                    <a:solidFill>
-                      <a:srgbClr val="DFE7ED"/>
-                    </a:solidFill>
-                  </a:tcPr>
-                </a:tc>
-                <a:extLst>
-                  <a:ext uri="{0D108BD9-81ED-4DB2-BD59-A6C34878D82A}">
-                    <a16:rowId xmlns:a16="http://schemas.microsoft.com/office/drawing/2014/main" val="10005"/>
-                  </a:ext>
-                </a:extLst>
-              </a:tr>
-            </a:tbl>
-          </a:graphicData>
-        </a:graphic>
-      </p:graphicFrame>
-      <p:sp>
-        <p:nvSpPr>
-          <p:cNvPr id="6" name="Shape 2"/>
-          <p:cNvSpPr/>
-          <p:nvPr/>
-        </p:nvSpPr>
-        <p:spPr>
-          <a:xfrm>
-            <a:off x="457200" y="4526280"/>
-            <a:ext cx="1965960" cy="411480"/>
-          </a:xfrm>
-          <a:prstGeom prst="roundRect">
-            <a:avLst>
-              <a:gd name="adj" fmla="val 8889"/>
-            </a:avLst>
-          </a:prstGeom>
-          <a:solidFill>
-            <a:srgbClr val="71D8C5"/>
-          </a:solidFill>
-          <a:ln w="9525">
-            <a:solidFill>
-              <a:srgbClr val="B7C4CC"/>
-            </a:solidFill>
-            <a:prstDash val="solid"/>
-          </a:ln>
-        </p:spPr>
-        <p:txBody>
-          <a:bodyPr/>
-          <a:lstStyle/>
-          <a:p>
-            <a:endParaRPr lang="en-US"/>
-          </a:p>
-        </p:txBody>
-      </p:sp>
-      <p:sp>
-        <p:nvSpPr>
-          <p:cNvPr id="7" name="Text 3"/>
-          <p:cNvSpPr/>
-          <p:nvPr/>
-        </p:nvSpPr>
-        <p:spPr>
-          <a:xfrm>
-            <a:off x="457200" y="4526280"/>
-            <a:ext cx="1965960" cy="411480"/>
-          </a:xfrm>
-          <a:prstGeom prst="rect">
-            <a:avLst/>
-          </a:prstGeom>
-          <a:noFill/>
-          <a:ln/>
-        </p:spPr>
-        <p:txBody>
-          <a:bodyPr wrap="square" rtlCol="0" anchor="ctr"/>
-          <a:lstStyle/>
-          <a:p>
-            <a:pPr marL="0" indent="0" algn="ctr">
-              <a:buNone/>
-            </a:pPr>
-            <a:r>
-              <a:rPr lang="en-US" sz="1000" b="1">
-                <a:solidFill>
-                  <a:srgbClr val="1B2227"/>
-                </a:solidFill>
-                <a:latin typeface="Arial" pitchFamily="34" charset="0"/>
-                <a:ea typeface="Arial" pitchFamily="34" charset="-122"/>
-                <a:cs typeface="Arial" pitchFamily="34" charset="-120"/>
-              </a:rPr>
-              <a:t>Distinction  25–30</a:t>
-            </a:r>
-            <a:endParaRPr lang="en-US" sz="1000"/>
-          </a:p>
-        </p:txBody>
-      </p:sp>
-      <p:sp>
-        <p:nvSpPr>
-          <p:cNvPr id="8" name="Shape 4"/>
-          <p:cNvSpPr/>
-          <p:nvPr/>
-        </p:nvSpPr>
-        <p:spPr>
-          <a:xfrm>
-            <a:off x="2532888" y="4526280"/>
-            <a:ext cx="1965960" cy="411480"/>
-          </a:xfrm>
-          <a:prstGeom prst="roundRect">
-            <a:avLst>
-              <a:gd name="adj" fmla="val 8889"/>
-            </a:avLst>
-          </a:prstGeom>
-          <a:solidFill>
-            <a:srgbClr val="C5DCEE"/>
-          </a:solidFill>
-          <a:ln w="9525">
-            <a:solidFill>
-              <a:srgbClr val="B7C4CC"/>
-            </a:solidFill>
-            <a:prstDash val="solid"/>
-          </a:ln>
-        </p:spPr>
-        <p:txBody>
-          <a:bodyPr/>
-          <a:lstStyle/>
-          <a:p>
-            <a:endParaRPr lang="en-US"/>
-          </a:p>
-        </p:txBody>
-      </p:sp>
-      <p:sp>
-        <p:nvSpPr>
-          <p:cNvPr id="9" name="Text 5"/>
-          <p:cNvSpPr/>
-          <p:nvPr/>
-        </p:nvSpPr>
-        <p:spPr>
-          <a:xfrm>
-            <a:off x="2532888" y="4526280"/>
-            <a:ext cx="1965960" cy="411480"/>
-          </a:xfrm>
-          <a:prstGeom prst="rect">
-            <a:avLst/>
-          </a:prstGeom>
-          <a:noFill/>
-          <a:ln/>
-        </p:spPr>
-        <p:txBody>
-          <a:bodyPr wrap="square" rtlCol="0" anchor="ctr"/>
-          <a:lstStyle/>
-          <a:p>
-            <a:pPr marL="0" indent="0" algn="ctr">
-              <a:buNone/>
-            </a:pPr>
-            <a:r>
-              <a:rPr lang="en-US" sz="1000" b="1">
-                <a:solidFill>
-                  <a:srgbClr val="1B2227"/>
-                </a:solidFill>
-                <a:latin typeface="Arial" pitchFamily="34" charset="0"/>
-                <a:ea typeface="Arial" pitchFamily="34" charset="-122"/>
-                <a:cs typeface="Arial" pitchFamily="34" charset="-120"/>
-              </a:rPr>
-              <a:t>Proficient  18–24</a:t>
-            </a:r>
-            <a:endParaRPr lang="en-US" sz="1000"/>
-          </a:p>
-        </p:txBody>
-      </p:sp>
-      <p:sp>
-        <p:nvSpPr>
-          <p:cNvPr id="10" name="Shape 6"/>
-          <p:cNvSpPr/>
-          <p:nvPr/>
-        </p:nvSpPr>
-        <p:spPr>
-          <a:xfrm>
-            <a:off x="4608576" y="4526280"/>
-            <a:ext cx="1965960" cy="411480"/>
-          </a:xfrm>
-          <a:prstGeom prst="roundRect">
-            <a:avLst>
-              <a:gd name="adj" fmla="val 8889"/>
-            </a:avLst>
-          </a:prstGeom>
-          <a:solidFill>
-            <a:srgbClr val="DFE7ED"/>
-          </a:solidFill>
-          <a:ln w="9525">
-            <a:solidFill>
-              <a:srgbClr val="B7C4CC"/>
-            </a:solidFill>
-            <a:prstDash val="solid"/>
-          </a:ln>
-        </p:spPr>
-        <p:txBody>
-          <a:bodyPr/>
-          <a:lstStyle/>
-          <a:p>
-            <a:endParaRPr lang="en-US"/>
-          </a:p>
-        </p:txBody>
-      </p:sp>
-      <p:sp>
-        <p:nvSpPr>
-          <p:cNvPr id="5" name="Text 7"/>
-          <p:cNvSpPr/>
-          <p:nvPr/>
-        </p:nvSpPr>
-        <p:spPr>
-          <a:xfrm>
-            <a:off x="4608576" y="4526280"/>
-            <a:ext cx="1965960" cy="411480"/>
-          </a:xfrm>
-          <a:prstGeom prst="rect">
-            <a:avLst/>
-          </a:prstGeom>
-          <a:noFill/>
-          <a:ln/>
-        </p:spPr>
-        <p:txBody>
-          <a:bodyPr wrap="square" rtlCol="0" anchor="ctr"/>
-          <a:lstStyle/>
-          <a:p>
-            <a:pPr marL="0" indent="0" algn="ctr">
-              <a:buNone/>
-            </a:pPr>
-            <a:r>
-              <a:rPr lang="en-US" sz="1000" b="1">
-                <a:solidFill>
-                  <a:srgbClr val="1B2227"/>
-                </a:solidFill>
-                <a:latin typeface="Arial" pitchFamily="34" charset="0"/>
-                <a:ea typeface="Arial" pitchFamily="34" charset="-122"/>
-                <a:cs typeface="Arial" pitchFamily="34" charset="-120"/>
-              </a:rPr>
-              <a:t>Developing  10–17</a:t>
-            </a:r>
-            <a:endParaRPr lang="en-US" sz="1000"/>
-          </a:p>
-        </p:txBody>
-      </p:sp>
-      <p:sp>
-        <p:nvSpPr>
-          <p:cNvPr id="12" name="Shape 8"/>
-          <p:cNvSpPr/>
-          <p:nvPr/>
-        </p:nvSpPr>
-        <p:spPr>
-          <a:xfrm>
-            <a:off x="6684264" y="4526280"/>
-            <a:ext cx="1965960" cy="411480"/>
-          </a:xfrm>
-          <a:prstGeom prst="roundRect">
-            <a:avLst>
-              <a:gd name="adj" fmla="val 8889"/>
-            </a:avLst>
-          </a:prstGeom>
-          <a:solidFill>
-            <a:srgbClr val="FFFFFF"/>
-          </a:solidFill>
-          <a:ln w="9525">
-            <a:solidFill>
-              <a:srgbClr val="B7C4CC"/>
-            </a:solidFill>
-            <a:prstDash val="solid"/>
-          </a:ln>
-        </p:spPr>
-        <p:txBody>
-          <a:bodyPr/>
-          <a:lstStyle/>
-          <a:p>
-            <a:endParaRPr lang="en-US"/>
-          </a:p>
-        </p:txBody>
-      </p:sp>
-      <p:sp>
-        <p:nvSpPr>
-          <p:cNvPr id="13" name="Text 9"/>
-          <p:cNvSpPr/>
-          <p:nvPr/>
-        </p:nvSpPr>
-        <p:spPr>
-          <a:xfrm>
-            <a:off x="6684264" y="4526280"/>
-            <a:ext cx="1965960" cy="411480"/>
-          </a:xfrm>
-          <a:prstGeom prst="rect">
-            <a:avLst/>
-          </a:prstGeom>
-          <a:noFill/>
-          <a:ln/>
-        </p:spPr>
-        <p:txBody>
-          <a:bodyPr wrap="square" rtlCol="0" anchor="ctr"/>
-          <a:lstStyle/>
-          <a:p>
-            <a:pPr marL="0" indent="0" algn="ctr">
-              <a:buNone/>
-            </a:pPr>
-            <a:r>
-              <a:rPr lang="en-US" sz="1000" b="1">
-                <a:solidFill>
-                  <a:srgbClr val="1B2227"/>
-                </a:solidFill>
-                <a:latin typeface="Arial" pitchFamily="34" charset="0"/>
-                <a:ea typeface="Arial" pitchFamily="34" charset="-122"/>
-                <a:cs typeface="Arial" pitchFamily="34" charset="-120"/>
-              </a:rPr>
-              <a:t>Emerging  0–9</a:t>
-            </a:r>
-            <a:endParaRPr lang="en-US" sz="1000"/>
-          </a:p>
-        </p:txBody>
-      </p:sp>
-    </p:spTree>
-  </p:cSld>
-  <p:clrMapOvr>
-    <a:masterClrMapping/>
-  </p:clrMapOvr>
-</p:sld>
-</file>
-
-<file path=ppt/slides/slide11.xml><?xml version="1.0" encoding="utf-8"?>
 <p:sld xmlns:a="http://schemas.openxmlformats.org/drawingml/2006/main" xmlns:r="http://schemas.openxmlformats.org/officeDocument/2006/relationships" xmlns:p="http://schemas.openxmlformats.org/presentationml/2006/main">
   <p:cSld name="Slide 11">
     <p:bg>
@@ -4749,7 +2922,7 @@
 </p:sld>
 </file>
 
-<file path=ppt/slides/slide12.xml><?xml version="1.0" encoding="utf-8"?>
+<file path=ppt/slides/slide11.xml><?xml version="1.0" encoding="utf-8"?>
 <p:sld xmlns:a="http://schemas.openxmlformats.org/drawingml/2006/main" xmlns:r="http://schemas.openxmlformats.org/officeDocument/2006/relationships" xmlns:p="http://schemas.openxmlformats.org/presentationml/2006/main">
   <p:cSld name="Slide 13">
     <p:bg>
@@ -5404,7 +3577,7 @@
 </p:sld>
 </file>
 
-<file path=ppt/slides/slide13.xml><?xml version="1.0" encoding="utf-8"?>
+<file path=ppt/slides/slide12.xml><?xml version="1.0" encoding="utf-8"?>
 <p:sld xmlns:a="http://schemas.openxmlformats.org/drawingml/2006/main" xmlns:r="http://schemas.openxmlformats.org/officeDocument/2006/relationships" xmlns:p="http://schemas.openxmlformats.org/presentationml/2006/main">
   <p:cSld name="Slide 12">
     <p:bg>
@@ -6383,761 +4556,6 @@
 
 <file path=ppt/slides/slide2.xml><?xml version="1.0" encoding="utf-8"?>
 <p:sld xmlns:a="http://schemas.openxmlformats.org/drawingml/2006/main" xmlns:r="http://schemas.openxmlformats.org/officeDocument/2006/relationships" xmlns:p="http://schemas.openxmlformats.org/presentationml/2006/main">
-  <p:cSld name="Slide 2">
-    <p:bg>
-      <p:bgPr>
-        <a:solidFill>
-          <a:srgbClr val="FFFFFF"/>
-        </a:solidFill>
-        <a:effectLst/>
-      </p:bgPr>
-    </p:bg>
-    <p:spTree>
-      <p:nvGrpSpPr>
-        <p:cNvPr id="1" name=""/>
-        <p:cNvGrpSpPr/>
-        <p:nvPr/>
-      </p:nvGrpSpPr>
-      <p:grpSpPr>
-        <a:xfrm>
-          <a:off x="0" y="0"/>
-          <a:ext cx="0" cy="0"/>
-          <a:chOff x="0" y="0"/>
-          <a:chExt cx="0" cy="0"/>
-        </a:xfrm>
-      </p:grpSpPr>
-      <p:sp>
-        <p:nvSpPr>
-          <p:cNvPr id="2" name="Text 0"/>
-          <p:cNvSpPr/>
-          <p:nvPr/>
-        </p:nvSpPr>
-        <p:spPr>
-          <a:xfrm>
-            <a:off x="457200" y="274320"/>
-            <a:ext cx="7498080" cy="548640"/>
-          </a:xfrm>
-          <a:prstGeom prst="rect">
-            <a:avLst/>
-          </a:prstGeom>
-          <a:noFill/>
-          <a:ln/>
-        </p:spPr>
-        <p:txBody>
-          <a:bodyPr wrap="square" rtlCol="0" anchor="ctr"/>
-          <a:lstStyle/>
-          <a:p>
-            <a:pPr marL="0" indent="0" algn="l">
-              <a:buNone/>
-            </a:pPr>
-            <a:r>
-              <a:rPr lang="en-US" sz="2600" b="1">
-                <a:solidFill>
-                  <a:srgbClr val="024879"/>
-                </a:solidFill>
-                <a:latin typeface="Arial" pitchFamily="34" charset="0"/>
-                <a:ea typeface="Arial" pitchFamily="34" charset="-122"/>
-                <a:cs typeface="Arial" pitchFamily="34" charset="-120"/>
-              </a:rPr>
-              <a:t>How to Use This Template</a:t>
-            </a:r>
-            <a:endParaRPr lang="en-US" sz="2600"/>
-          </a:p>
-        </p:txBody>
-      </p:sp>
-      <p:pic>
-        <p:nvPicPr>
-          <p:cNvPr id="3" name="Image 0" descr="preencoded.png"/>
-          <p:cNvPicPr>
-            <a:picLocks noChangeAspect="1"/>
-          </p:cNvPicPr>
-          <p:nvPr/>
-        </p:nvPicPr>
-        <p:blipFill>
-          <a:blip r:embed="rId3"/>
-          <a:stretch>
-            <a:fillRect/>
-          </a:stretch>
-        </p:blipFill>
-        <p:spPr>
-          <a:xfrm>
-            <a:off x="7818120" y="292608"/>
-            <a:ext cx="914400" cy="274730"/>
-          </a:xfrm>
-          <a:prstGeom prst="rect">
-            <a:avLst/>
-          </a:prstGeom>
-        </p:spPr>
-      </p:pic>
-      <p:sp>
-        <p:nvSpPr>
-          <p:cNvPr id="4" name="Shape 1"/>
-          <p:cNvSpPr/>
-          <p:nvPr/>
-        </p:nvSpPr>
-        <p:spPr>
-          <a:xfrm>
-            <a:off x="457200" y="1143000"/>
-            <a:ext cx="310896" cy="310896"/>
-          </a:xfrm>
-          <a:prstGeom prst="ellipse">
-            <a:avLst/>
-          </a:prstGeom>
-          <a:solidFill>
-            <a:srgbClr val="075056"/>
-          </a:solidFill>
-          <a:ln/>
-        </p:spPr>
-        <p:txBody>
-          <a:bodyPr/>
-          <a:lstStyle/>
-          <a:p>
-            <a:endParaRPr lang="en-US"/>
-          </a:p>
-        </p:txBody>
-      </p:sp>
-      <p:sp>
-        <p:nvSpPr>
-          <p:cNvPr id="5" name="Text 2"/>
-          <p:cNvSpPr/>
-          <p:nvPr/>
-        </p:nvSpPr>
-        <p:spPr>
-          <a:xfrm>
-            <a:off x="457200" y="1143000"/>
-            <a:ext cx="310896" cy="310896"/>
-          </a:xfrm>
-          <a:prstGeom prst="rect">
-            <a:avLst/>
-          </a:prstGeom>
-          <a:noFill/>
-          <a:ln/>
-        </p:spPr>
-        <p:txBody>
-          <a:bodyPr wrap="square" rtlCol="0" anchor="ctr"/>
-          <a:lstStyle/>
-          <a:p>
-            <a:pPr marL="0" indent="0" algn="ctr">
-              <a:buNone/>
-            </a:pPr>
-            <a:r>
-              <a:rPr lang="en-US" sz="1400" b="1">
-                <a:solidFill>
-                  <a:srgbClr val="FFFFFF"/>
-                </a:solidFill>
-                <a:latin typeface="Arial" pitchFamily="34" charset="0"/>
-                <a:ea typeface="Arial" pitchFamily="34" charset="-122"/>
-                <a:cs typeface="Arial" pitchFamily="34" charset="-120"/>
-              </a:rPr>
-              <a:t>1</a:t>
-            </a:r>
-            <a:endParaRPr lang="en-US" sz="1400"/>
-          </a:p>
-        </p:txBody>
-      </p:sp>
-      <p:sp>
-        <p:nvSpPr>
-          <p:cNvPr id="6" name="Text 3"/>
-          <p:cNvSpPr/>
-          <p:nvPr/>
-        </p:nvSpPr>
-        <p:spPr>
-          <a:xfrm>
-            <a:off x="914400" y="1097280"/>
-            <a:ext cx="7680960" cy="457200"/>
-          </a:xfrm>
-          <a:prstGeom prst="rect">
-            <a:avLst/>
-          </a:prstGeom>
-          <a:noFill/>
-          <a:ln/>
-        </p:spPr>
-        <p:txBody>
-          <a:bodyPr wrap="square" rtlCol="0" anchor="ctr"/>
-          <a:lstStyle/>
-          <a:p>
-            <a:pPr marL="0" indent="0">
-              <a:buNone/>
-            </a:pPr>
-            <a:r>
-              <a:rPr lang="en-US" sz="1300" b="1">
-                <a:solidFill>
-                  <a:srgbClr val="024879"/>
-                </a:solidFill>
-                <a:latin typeface="Calibri" pitchFamily="34" charset="0"/>
-                <a:ea typeface="Calibri" pitchFamily="34" charset="-122"/>
-                <a:cs typeface="Calibri" pitchFamily="34" charset="-120"/>
-              </a:rPr>
-              <a:t>Pick your option  </a:t>
-            </a:r>
-            <a:r>
-              <a:rPr lang="en-US" sz="1300">
-                <a:solidFill>
-                  <a:srgbClr val="1B2227"/>
-                </a:solidFill>
-                <a:latin typeface="Calibri" pitchFamily="34" charset="0"/>
-                <a:ea typeface="Calibri" pitchFamily="34" charset="-122"/>
-                <a:cs typeface="Calibri" pitchFamily="34" charset="-120"/>
-              </a:rPr>
-              <a:t>Keep Option 1 (client work) or Option 2 (platform contribution) or Option 4 (AI Case Study). Fill every slide; delete instruction notes.</a:t>
-            </a:r>
-            <a:endParaRPr lang="en-US" sz="1300"/>
-          </a:p>
-        </p:txBody>
-      </p:sp>
-      <p:sp>
-        <p:nvSpPr>
-          <p:cNvPr id="7" name="Shape 4"/>
-          <p:cNvSpPr/>
-          <p:nvPr/>
-        </p:nvSpPr>
-        <p:spPr>
-          <a:xfrm>
-            <a:off x="457200" y="1709928"/>
-            <a:ext cx="310896" cy="310896"/>
-          </a:xfrm>
-          <a:prstGeom prst="ellipse">
-            <a:avLst/>
-          </a:prstGeom>
-          <a:solidFill>
-            <a:srgbClr val="075056"/>
-          </a:solidFill>
-          <a:ln/>
-        </p:spPr>
-        <p:txBody>
-          <a:bodyPr/>
-          <a:lstStyle/>
-          <a:p>
-            <a:endParaRPr lang="en-US"/>
-          </a:p>
-        </p:txBody>
-      </p:sp>
-      <p:sp>
-        <p:nvSpPr>
-          <p:cNvPr id="8" name="Text 5"/>
-          <p:cNvSpPr/>
-          <p:nvPr/>
-        </p:nvSpPr>
-        <p:spPr>
-          <a:xfrm>
-            <a:off x="457200" y="1709928"/>
-            <a:ext cx="310896" cy="310896"/>
-          </a:xfrm>
-          <a:prstGeom prst="rect">
-            <a:avLst/>
-          </a:prstGeom>
-          <a:noFill/>
-          <a:ln/>
-        </p:spPr>
-        <p:txBody>
-          <a:bodyPr wrap="square" rtlCol="0" anchor="ctr"/>
-          <a:lstStyle/>
-          <a:p>
-            <a:pPr marL="0" indent="0" algn="ctr">
-              <a:buNone/>
-            </a:pPr>
-            <a:r>
-              <a:rPr lang="en-US" sz="1400" b="1">
-                <a:solidFill>
-                  <a:srgbClr val="FFFFFF"/>
-                </a:solidFill>
-                <a:latin typeface="Arial" pitchFamily="34" charset="0"/>
-                <a:ea typeface="Arial" pitchFamily="34" charset="-122"/>
-                <a:cs typeface="Arial" pitchFamily="34" charset="-120"/>
-              </a:rPr>
-              <a:t>2</a:t>
-            </a:r>
-            <a:endParaRPr lang="en-US" sz="1400"/>
-          </a:p>
-        </p:txBody>
-      </p:sp>
-      <p:sp>
-        <p:nvSpPr>
-          <p:cNvPr id="9" name="Text 6"/>
-          <p:cNvSpPr/>
-          <p:nvPr/>
-        </p:nvSpPr>
-        <p:spPr>
-          <a:xfrm>
-            <a:off x="914400" y="1664208"/>
-            <a:ext cx="7680960" cy="457200"/>
-          </a:xfrm>
-          <a:prstGeom prst="rect">
-            <a:avLst/>
-          </a:prstGeom>
-          <a:noFill/>
-          <a:ln/>
-        </p:spPr>
-        <p:txBody>
-          <a:bodyPr wrap="square" rtlCol="0" anchor="ctr"/>
-          <a:lstStyle/>
-          <a:p>
-            <a:pPr marL="0" indent="0">
-              <a:buNone/>
-            </a:pPr>
-            <a:r>
-              <a:rPr lang="en-US" sz="1300" b="1">
-                <a:solidFill>
-                  <a:srgbClr val="024879"/>
-                </a:solidFill>
-                <a:latin typeface="Calibri" pitchFamily="34" charset="0"/>
-                <a:ea typeface="Calibri" pitchFamily="34" charset="-122"/>
-                <a:cs typeface="Calibri" pitchFamily="34" charset="-120"/>
-              </a:rPr>
-              <a:t>Show at least 3 of 5 competencies  </a:t>
-            </a:r>
-            <a:r>
-              <a:rPr lang="en-US" sz="1300">
-                <a:solidFill>
-                  <a:srgbClr val="1B2227"/>
-                </a:solidFill>
-                <a:latin typeface="Calibri" pitchFamily="34" charset="0"/>
-                <a:ea typeface="Calibri" pitchFamily="34" charset="-122"/>
-                <a:cs typeface="Calibri" pitchFamily="34" charset="-120"/>
-              </a:rPr>
-              <a:t>The rubric has 5 topics. Demonstrate a minimum of 3 with real evidence.</a:t>
-            </a:r>
-            <a:endParaRPr lang="en-US" sz="1300"/>
-          </a:p>
-        </p:txBody>
-      </p:sp>
-      <p:sp>
-        <p:nvSpPr>
-          <p:cNvPr id="10" name="Shape 7"/>
-          <p:cNvSpPr/>
-          <p:nvPr/>
-        </p:nvSpPr>
-        <p:spPr>
-          <a:xfrm>
-            <a:off x="457200" y="2276856"/>
-            <a:ext cx="310896" cy="310896"/>
-          </a:xfrm>
-          <a:prstGeom prst="ellipse">
-            <a:avLst/>
-          </a:prstGeom>
-          <a:solidFill>
-            <a:srgbClr val="075056"/>
-          </a:solidFill>
-          <a:ln/>
-        </p:spPr>
-        <p:txBody>
-          <a:bodyPr/>
-          <a:lstStyle/>
-          <a:p>
-            <a:endParaRPr lang="en-US"/>
-          </a:p>
-        </p:txBody>
-      </p:sp>
-      <p:sp>
-        <p:nvSpPr>
-          <p:cNvPr id="11" name="Text 8"/>
-          <p:cNvSpPr/>
-          <p:nvPr/>
-        </p:nvSpPr>
-        <p:spPr>
-          <a:xfrm>
-            <a:off x="457200" y="2276856"/>
-            <a:ext cx="310896" cy="310896"/>
-          </a:xfrm>
-          <a:prstGeom prst="rect">
-            <a:avLst/>
-          </a:prstGeom>
-          <a:noFill/>
-          <a:ln/>
-        </p:spPr>
-        <p:txBody>
-          <a:bodyPr wrap="square" rtlCol="0" anchor="ctr"/>
-          <a:lstStyle/>
-          <a:p>
-            <a:pPr marL="0" indent="0" algn="ctr">
-              <a:buNone/>
-            </a:pPr>
-            <a:r>
-              <a:rPr lang="en-US" sz="1400" b="1">
-                <a:solidFill>
-                  <a:srgbClr val="FFFFFF"/>
-                </a:solidFill>
-                <a:latin typeface="Arial" pitchFamily="34" charset="0"/>
-                <a:ea typeface="Arial" pitchFamily="34" charset="-122"/>
-                <a:cs typeface="Arial" pitchFamily="34" charset="-120"/>
-              </a:rPr>
-              <a:t>3</a:t>
-            </a:r>
-            <a:endParaRPr lang="en-US" sz="1400"/>
-          </a:p>
-        </p:txBody>
-      </p:sp>
-      <p:sp>
-        <p:nvSpPr>
-          <p:cNvPr id="12" name="Text 9"/>
-          <p:cNvSpPr/>
-          <p:nvPr/>
-        </p:nvSpPr>
-        <p:spPr>
-          <a:xfrm>
-            <a:off x="914400" y="2231136"/>
-            <a:ext cx="7680960" cy="457200"/>
-          </a:xfrm>
-          <a:prstGeom prst="rect">
-            <a:avLst/>
-          </a:prstGeom>
-          <a:noFill/>
-          <a:ln/>
-        </p:spPr>
-        <p:txBody>
-          <a:bodyPr wrap="square" rtlCol="0" anchor="ctr"/>
-          <a:lstStyle/>
-          <a:p>
-            <a:pPr marL="0" indent="0">
-              <a:buNone/>
-            </a:pPr>
-            <a:r>
-              <a:rPr lang="en-US" sz="1300" b="1">
-                <a:solidFill>
-                  <a:srgbClr val="024879"/>
-                </a:solidFill>
-                <a:latin typeface="Calibri" pitchFamily="34" charset="0"/>
-                <a:ea typeface="Calibri" pitchFamily="34" charset="-122"/>
-                <a:cs typeface="Calibri" pitchFamily="34" charset="-120"/>
-              </a:rPr>
-              <a:t>Capture impact &amp; reusability  </a:t>
-            </a:r>
-            <a:r>
-              <a:rPr lang="en-US" sz="1300">
-                <a:solidFill>
-                  <a:srgbClr val="1B2227"/>
-                </a:solidFill>
-                <a:latin typeface="Calibri" pitchFamily="34" charset="0"/>
-                <a:ea typeface="Calibri" pitchFamily="34" charset="-122"/>
-                <a:cs typeface="Calibri" pitchFamily="34" charset="-120"/>
-              </a:rPr>
-              <a:t>Quantify before/after and show whether others can reuse your work.</a:t>
-            </a:r>
-            <a:endParaRPr lang="en-US" sz="1300"/>
-          </a:p>
-        </p:txBody>
-      </p:sp>
-      <p:sp>
-        <p:nvSpPr>
-          <p:cNvPr id="13" name="Shape 10"/>
-          <p:cNvSpPr/>
-          <p:nvPr/>
-        </p:nvSpPr>
-        <p:spPr>
-          <a:xfrm>
-            <a:off x="457200" y="2843784"/>
-            <a:ext cx="310896" cy="310896"/>
-          </a:xfrm>
-          <a:prstGeom prst="ellipse">
-            <a:avLst/>
-          </a:prstGeom>
-          <a:solidFill>
-            <a:srgbClr val="024879"/>
-          </a:solidFill>
-          <a:ln/>
-        </p:spPr>
-        <p:txBody>
-          <a:bodyPr/>
-          <a:lstStyle/>
-          <a:p>
-            <a:endParaRPr lang="en-US"/>
-          </a:p>
-        </p:txBody>
-      </p:sp>
-      <p:sp>
-        <p:nvSpPr>
-          <p:cNvPr id="14" name="Text 11"/>
-          <p:cNvSpPr/>
-          <p:nvPr/>
-        </p:nvSpPr>
-        <p:spPr>
-          <a:xfrm>
-            <a:off x="457200" y="2843784"/>
-            <a:ext cx="310896" cy="310896"/>
-          </a:xfrm>
-          <a:prstGeom prst="rect">
-            <a:avLst/>
-          </a:prstGeom>
-          <a:noFill/>
-          <a:ln/>
-        </p:spPr>
-        <p:txBody>
-          <a:bodyPr wrap="square" rtlCol="0" anchor="ctr"/>
-          <a:lstStyle/>
-          <a:p>
-            <a:pPr marL="0" indent="0" algn="ctr">
-              <a:buNone/>
-            </a:pPr>
-            <a:r>
-              <a:rPr lang="en-US" sz="1400" b="1">
-                <a:solidFill>
-                  <a:srgbClr val="FFFFFF"/>
-                </a:solidFill>
-                <a:latin typeface="Arial" pitchFamily="34" charset="0"/>
-                <a:ea typeface="Arial" pitchFamily="34" charset="-122"/>
-                <a:cs typeface="Arial" pitchFamily="34" charset="-120"/>
-              </a:rPr>
-              <a:t>4</a:t>
-            </a:r>
-            <a:endParaRPr lang="en-US" sz="1400"/>
-          </a:p>
-        </p:txBody>
-      </p:sp>
-      <p:sp>
-        <p:nvSpPr>
-          <p:cNvPr id="15" name="Text 12"/>
-          <p:cNvSpPr/>
-          <p:nvPr/>
-        </p:nvSpPr>
-        <p:spPr>
-          <a:xfrm>
-            <a:off x="914400" y="2798064"/>
-            <a:ext cx="7680960" cy="457200"/>
-          </a:xfrm>
-          <a:prstGeom prst="rect">
-            <a:avLst/>
-          </a:prstGeom>
-          <a:noFill/>
-          <a:ln/>
-        </p:spPr>
-        <p:txBody>
-          <a:bodyPr wrap="square" rtlCol="0" anchor="ctr"/>
-          <a:lstStyle/>
-          <a:p>
-            <a:pPr marL="0" indent="0">
-              <a:buNone/>
-            </a:pPr>
-            <a:r>
-              <a:rPr lang="en-US" sz="1300" b="1">
-                <a:solidFill>
-                  <a:srgbClr val="024879"/>
-                </a:solidFill>
-                <a:latin typeface="Calibri" pitchFamily="34" charset="0"/>
-                <a:ea typeface="Calibri" pitchFamily="34" charset="-122"/>
-                <a:cs typeface="Calibri" pitchFamily="34" charset="-120"/>
-              </a:rPr>
-              <a:t>Self-rate honestly  </a:t>
-            </a:r>
-            <a:r>
-              <a:rPr lang="en-US" sz="1300">
-                <a:solidFill>
-                  <a:srgbClr val="1B2227"/>
-                </a:solidFill>
-                <a:latin typeface="Calibri" pitchFamily="34" charset="0"/>
-                <a:ea typeface="Calibri" pitchFamily="34" charset="-122"/>
-                <a:cs typeface="Calibri" pitchFamily="34" charset="-120"/>
-              </a:rPr>
-              <a:t>Score each topic 0–30 on the Self-Rating slide. Attach evidence for every claim.</a:t>
-            </a:r>
-            <a:endParaRPr lang="en-US" sz="1300"/>
-          </a:p>
-        </p:txBody>
-      </p:sp>
-      <p:sp>
-        <p:nvSpPr>
-          <p:cNvPr id="16" name="Shape 13"/>
-          <p:cNvSpPr/>
-          <p:nvPr/>
-        </p:nvSpPr>
-        <p:spPr>
-          <a:xfrm>
-            <a:off x="457200" y="3410712"/>
-            <a:ext cx="310896" cy="310896"/>
-          </a:xfrm>
-          <a:prstGeom prst="ellipse">
-            <a:avLst/>
-          </a:prstGeom>
-          <a:solidFill>
-            <a:srgbClr val="024879"/>
-          </a:solidFill>
-          <a:ln/>
-        </p:spPr>
-        <p:txBody>
-          <a:bodyPr/>
-          <a:lstStyle/>
-          <a:p>
-            <a:endParaRPr lang="en-US"/>
-          </a:p>
-        </p:txBody>
-      </p:sp>
-      <p:sp>
-        <p:nvSpPr>
-          <p:cNvPr id="17" name="Text 14"/>
-          <p:cNvSpPr/>
-          <p:nvPr/>
-        </p:nvSpPr>
-        <p:spPr>
-          <a:xfrm>
-            <a:off x="457200" y="3410712"/>
-            <a:ext cx="310896" cy="310896"/>
-          </a:xfrm>
-          <a:prstGeom prst="rect">
-            <a:avLst/>
-          </a:prstGeom>
-          <a:noFill/>
-          <a:ln/>
-        </p:spPr>
-        <p:txBody>
-          <a:bodyPr wrap="square" rtlCol="0" anchor="ctr"/>
-          <a:lstStyle/>
-          <a:p>
-            <a:pPr marL="0" indent="0" algn="ctr">
-              <a:buNone/>
-            </a:pPr>
-            <a:r>
-              <a:rPr lang="en-US" sz="1400" b="1">
-                <a:solidFill>
-                  <a:srgbClr val="FFFFFF"/>
-                </a:solidFill>
-                <a:latin typeface="Arial" pitchFamily="34" charset="0"/>
-                <a:ea typeface="Arial" pitchFamily="34" charset="-122"/>
-                <a:cs typeface="Arial" pitchFamily="34" charset="-120"/>
-              </a:rPr>
-              <a:t>5</a:t>
-            </a:r>
-            <a:endParaRPr lang="en-US" sz="1400"/>
-          </a:p>
-        </p:txBody>
-      </p:sp>
-      <p:sp>
-        <p:nvSpPr>
-          <p:cNvPr id="18" name="Text 15"/>
-          <p:cNvSpPr/>
-          <p:nvPr/>
-        </p:nvSpPr>
-        <p:spPr>
-          <a:xfrm>
-            <a:off x="914400" y="3364992"/>
-            <a:ext cx="7680960" cy="457200"/>
-          </a:xfrm>
-          <a:prstGeom prst="rect">
-            <a:avLst/>
-          </a:prstGeom>
-          <a:noFill/>
-          <a:ln/>
-        </p:spPr>
-        <p:txBody>
-          <a:bodyPr wrap="square" rtlCol="0" anchor="ctr"/>
-          <a:lstStyle/>
-          <a:p>
-            <a:pPr marL="0" indent="0">
-              <a:buNone/>
-            </a:pPr>
-            <a:r>
-              <a:rPr lang="en-US" sz="1300" b="1">
-                <a:solidFill>
-                  <a:srgbClr val="024879"/>
-                </a:solidFill>
-                <a:latin typeface="Calibri" pitchFamily="34" charset="0"/>
-                <a:ea typeface="Calibri" pitchFamily="34" charset="-122"/>
-                <a:cs typeface="Calibri" pitchFamily="34" charset="-120"/>
-              </a:rPr>
-              <a:t>Route to your validator  </a:t>
-            </a:r>
-            <a:r>
-              <a:rPr lang="en-US" sz="1300">
-                <a:solidFill>
-                  <a:srgbClr val="1B2227"/>
-                </a:solidFill>
-                <a:latin typeface="Calibri" pitchFamily="34" charset="0"/>
-                <a:ea typeface="Calibri" pitchFamily="34" charset="-122"/>
-                <a:cs typeface="Calibri" pitchFamily="34" charset="-120"/>
-              </a:rPr>
-              <a:t>Your named validator scores and signs off: Agree or Do not certify.</a:t>
-            </a:r>
-            <a:endParaRPr lang="en-US" sz="1300"/>
-          </a:p>
-        </p:txBody>
-      </p:sp>
-      <p:sp>
-        <p:nvSpPr>
-          <p:cNvPr id="19" name="Shape 16"/>
-          <p:cNvSpPr/>
-          <p:nvPr/>
-        </p:nvSpPr>
-        <p:spPr>
-          <a:xfrm>
-            <a:off x="457200" y="4160520"/>
-            <a:ext cx="8229600" cy="640080"/>
-          </a:xfrm>
-          <a:prstGeom prst="roundRect">
-            <a:avLst>
-              <a:gd name="adj" fmla="val 8571"/>
-            </a:avLst>
-          </a:prstGeom>
-          <a:solidFill>
-            <a:srgbClr val="075056"/>
-          </a:solidFill>
-          <a:ln/>
-        </p:spPr>
-        <p:txBody>
-          <a:bodyPr/>
-          <a:lstStyle/>
-          <a:p>
-            <a:endParaRPr lang="en-US"/>
-          </a:p>
-        </p:txBody>
-      </p:sp>
-      <p:sp>
-        <p:nvSpPr>
-          <p:cNvPr id="20" name="Text 17"/>
-          <p:cNvSpPr/>
-          <p:nvPr/>
-        </p:nvSpPr>
-        <p:spPr>
-          <a:xfrm>
-            <a:off x="640080" y="4160520"/>
-            <a:ext cx="7863840" cy="640080"/>
-          </a:xfrm>
-          <a:prstGeom prst="rect">
-            <a:avLst/>
-          </a:prstGeom>
-          <a:noFill/>
-          <a:ln/>
-        </p:spPr>
-        <p:txBody>
-          <a:bodyPr wrap="square" rtlCol="0" anchor="ctr"/>
-          <a:lstStyle/>
-          <a:p>
-            <a:pPr marL="0" indent="0">
-              <a:buNone/>
-            </a:pPr>
-            <a:r>
-              <a:rPr lang="en-US" sz="1600" b="1">
-                <a:solidFill>
-                  <a:srgbClr val="FFFFFF"/>
-                </a:solidFill>
-                <a:latin typeface="Arial" pitchFamily="34" charset="0"/>
-                <a:ea typeface="Arial" pitchFamily="34" charset="-122"/>
-                <a:cs typeface="Arial" pitchFamily="34" charset="-120"/>
-              </a:rPr>
-              <a:t>Score to clear:  70 / 150 minimum</a:t>
-            </a:r>
-            <a:r>
-              <a:rPr lang="en-US" sz="1200">
-                <a:solidFill>
-                  <a:srgbClr val="71D8C5"/>
-                </a:solidFill>
-                <a:latin typeface="Arial" pitchFamily="34" charset="0"/>
-                <a:ea typeface="Arial" pitchFamily="34" charset="-122"/>
-                <a:cs typeface="Arial" pitchFamily="34" charset="-120"/>
-              </a:rPr>
-              <a:t>     •  5 topics × 30 max each  •  minimum 3 topics demonstrated</a:t>
-            </a:r>
-            <a:endParaRPr lang="en-US" sz="1600"/>
-          </a:p>
-        </p:txBody>
-      </p:sp>
-    </p:spTree>
-  </p:cSld>
-  <p:clrMapOvr>
-    <a:masterClrMapping/>
-  </p:clrMapOvr>
-</p:sld>
-</file>
-
-<file path=ppt/slides/slide3.xml><?xml version="1.0" encoding="utf-8"?>
-<p:sld xmlns:a="http://schemas.openxmlformats.org/drawingml/2006/main" xmlns:r="http://schemas.openxmlformats.org/officeDocument/2006/relationships" xmlns:p="http://schemas.openxmlformats.org/presentationml/2006/main">
   <p:cSld name="Slide 3">
     <p:bg>
       <p:bgPr>
@@ -8079,7 +5497,7 @@
 </p:sld>
 </file>
 
-<file path=ppt/slides/slide4.xml><?xml version="1.0" encoding="utf-8"?>
+<file path=ppt/slides/slide3.xml><?xml version="1.0" encoding="utf-8"?>
 <p:sld xmlns:a="http://schemas.openxmlformats.org/drawingml/2006/main" xmlns:r="http://schemas.openxmlformats.org/officeDocument/2006/relationships" xmlns:p="http://schemas.openxmlformats.org/presentationml/2006/main">
   <p:cSld name="Slide 4">
     <p:bg>
@@ -9191,7 +6609,7 @@
 </p:sld>
 </file>
 
-<file path=ppt/slides/slide5.xml><?xml version="1.0" encoding="utf-8"?>
+<file path=ppt/slides/slide4.xml><?xml version="1.0" encoding="utf-8"?>
 <p:sld xmlns:a="http://schemas.openxmlformats.org/drawingml/2006/main" xmlns:r="http://schemas.openxmlformats.org/officeDocument/2006/relationships" xmlns:p="http://schemas.openxmlformats.org/presentationml/2006/main">
   <p:cSld name="Slide 5">
     <p:bg>
@@ -9674,7 +7092,7 @@
 </p:sld>
 </file>
 
-<file path=ppt/slides/slide6.xml><?xml version="1.0" encoding="utf-8"?>
+<file path=ppt/slides/slide5.xml><?xml version="1.0" encoding="utf-8"?>
 <p:sld xmlns:a="http://schemas.openxmlformats.org/drawingml/2006/main" xmlns:r="http://schemas.openxmlformats.org/officeDocument/2006/relationships" xmlns:p="http://schemas.openxmlformats.org/presentationml/2006/main">
   <p:cSld name="Slide 6">
     <p:bg>
@@ -11573,7 +8991,7 @@
 </p:sld>
 </file>
 
-<file path=ppt/slides/slide7.xml><?xml version="1.0" encoding="utf-8"?>
+<file path=ppt/slides/slide6.xml><?xml version="1.0" encoding="utf-8"?>
 <p:sld xmlns:a="http://schemas.openxmlformats.org/drawingml/2006/main" xmlns:r="http://schemas.openxmlformats.org/officeDocument/2006/relationships" xmlns:p="http://schemas.openxmlformats.org/presentationml/2006/main">
   <p:cSld name="Slide 7">
     <p:bg>
@@ -12361,7 +9779,7 @@
 </p:sld>
 </file>
 
-<file path=ppt/slides/slide8.xml><?xml version="1.0" encoding="utf-8"?>
+<file path=ppt/slides/slide7.xml><?xml version="1.0" encoding="utf-8"?>
 <p:sld xmlns:a="http://schemas.openxmlformats.org/drawingml/2006/main" xmlns:r="http://schemas.openxmlformats.org/officeDocument/2006/relationships" xmlns:p="http://schemas.openxmlformats.org/presentationml/2006/main">
   <p:cSld name="Slide 8">
     <p:bg>
@@ -12916,7 +10334,7 @@
 </p:sld>
 </file>
 
-<file path=ppt/slides/slide9.xml><?xml version="1.0" encoding="utf-8"?>
+<file path=ppt/slides/slide8.xml><?xml version="1.0" encoding="utf-8"?>
 <p:sld xmlns:a="http://schemas.openxmlformats.org/drawingml/2006/main" xmlns:r="http://schemas.openxmlformats.org/officeDocument/2006/relationships" xmlns:p="http://schemas.openxmlformats.org/presentationml/2006/main">
   <p:cSld name="Slide 9">
     <p:bg>
@@ -13076,7 +10494,7 @@
                 <a:ea typeface="Calibri" pitchFamily="34" charset="-122"/>
                 <a:cs typeface="Calibri" pitchFamily="34" charset="-120"/>
               </a:rPr>
-              <a:t>•  PR link(s) / merged commits</a:t>
+              <a:t>•  Repo &amp; branch — all code</a:t>
             </a:r>
             <a:endParaRPr lang="en-US" sz="1150"/>
           </a:p>
@@ -13148,8 +10566,9 @@
                 <a:latin typeface="Calibri" pitchFamily="34" charset="0"/>
                 <a:ea typeface="Calibri" pitchFamily="34" charset="-122"/>
                 <a:cs typeface="Calibri" pitchFamily="34" charset="-120"/>
-              </a:rPr>
-              <a:t>capstone-ai-dlc/ — 18 SQL scripts</a:t>
+                <a:hlinkClick r:id="rId4"/>
+              </a:rPr>
+              <a:t>dbt_capstone @ capstone_L2</a:t>
             </a:r>
             <a:endParaRPr lang="en-US" sz="1100"/>
           </a:p>
@@ -13188,7 +10607,7 @@
                 <a:ea typeface="Calibri" pitchFamily="34" charset="-122"/>
                 <a:cs typeface="Calibri" pitchFamily="34" charset="-120"/>
               </a:rPr>
-              <a:t>•  Design docs / demo recording</a:t>
+              <a:t>•  Write-up / design doc</a:t>
             </a:r>
             <a:endParaRPr lang="en-US" sz="1150"/>
           </a:p>
@@ -13260,6 +10679,7 @@
                 <a:latin typeface="Calibri" pitchFamily="34" charset="0"/>
                 <a:ea typeface="Calibri" pitchFamily="34" charset="-122"/>
                 <a:cs typeface="Calibri" pitchFamily="34" charset="-120"/>
+                <a:hlinkClick r:id="rId5"/>
               </a:rPr>
               <a:t>docs/CAPSTONE.md</a:t>
             </a:r>
@@ -13365,15 +10785,16 @@
               <a:buNone/>
             </a:pPr>
             <a:r>
-              <a:rPr lang="en-US" sz="900" i="1">
+              <a:rPr lang="en-US" sz="800" i="1">
                 <a:solidFill>
                   <a:srgbClr val="5A6B72"/>
                 </a:solidFill>
                 <a:latin typeface="Calibri" pitchFamily="34" charset="0"/>
                 <a:ea typeface="Calibri" pitchFamily="34" charset="-122"/>
                 <a:cs typeface="Calibri" pitchFamily="34" charset="-120"/>
-              </a:rPr>
-              <a:t>METRICS.AGENT_RUN_LOG</a:t>
+                <a:hlinkClick r:id="rId6"/>
+              </a:rPr>
+              <a:t>METRICS.AGENT_RUN_LOG · sql/05</a:t>
             </a:r>
             <a:endParaRPr lang="en-US" sz="1100"/>
           </a:p>
@@ -13412,7 +10833,7 @@
                 <a:ea typeface="Calibri" pitchFamily="34" charset="-122"/>
                 <a:cs typeface="Calibri" pitchFamily="34" charset="-120"/>
               </a:rPr>
-              <a:t>•  Screenshots on the slides above</a:t>
+              <a:t>•  Dashboard source (screenshots above)</a:t>
             </a:r>
             <a:endParaRPr lang="en-US" sz="1150"/>
           </a:p>
@@ -13484,8 +10905,9 @@
                 <a:latin typeface="Calibri" pitchFamily="34" charset="0"/>
                 <a:ea typeface="Calibri" pitchFamily="34" charset="-122"/>
                 <a:cs typeface="Calibri" pitchFamily="34" charset="-120"/>
-              </a:rPr>
-              <a:t>APP.CAPSTONE_DASHBOARD</a:t>
+                <a:hlinkClick r:id="rId7"/>
+              </a:rPr>
+              <a:t>app/streamlit_app.py</a:t>
             </a:r>
             <a:endParaRPr lang="en-US" sz="1100"/>
           </a:p>
@@ -13689,6 +11111,1748 @@
               <a:t>____________________</a:t>
             </a:r>
             <a:endParaRPr lang="en-US" sz="1200"/>
+          </a:p>
+        </p:txBody>
+      </p:sp>
+    </p:spTree>
+  </p:cSld>
+  <p:clrMapOvr>
+    <a:masterClrMapping/>
+  </p:clrMapOvr>
+</p:sld>
+</file>
+
+<file path=ppt/slides/slide9.xml><?xml version="1.0" encoding="utf-8"?>
+<p:sld xmlns:a="http://schemas.openxmlformats.org/drawingml/2006/main" xmlns:r="http://schemas.openxmlformats.org/officeDocument/2006/relationships" xmlns:p="http://schemas.openxmlformats.org/presentationml/2006/main">
+  <p:cSld name="Slide 10">
+    <p:bg>
+      <p:bgPr>
+        <a:solidFill>
+          <a:srgbClr val="FFFFFF"/>
+        </a:solidFill>
+        <a:effectLst/>
+      </p:bgPr>
+    </p:bg>
+    <p:spTree>
+      <p:nvGrpSpPr>
+        <p:cNvPr id="1" name=""/>
+        <p:cNvGrpSpPr/>
+        <p:nvPr/>
+      </p:nvGrpSpPr>
+      <p:grpSpPr>
+        <a:xfrm>
+          <a:off x="0" y="0"/>
+          <a:ext cx="0" cy="0"/>
+          <a:chOff x="0" y="0"/>
+          <a:chExt cx="0" cy="0"/>
+        </a:xfrm>
+      </p:grpSpPr>
+      <p:sp>
+        <p:nvSpPr>
+          <p:cNvPr id="2" name="Text 0"/>
+          <p:cNvSpPr/>
+          <p:nvPr/>
+        </p:nvSpPr>
+        <p:spPr>
+          <a:xfrm>
+            <a:off x="457200" y="274320"/>
+            <a:ext cx="7498080" cy="548640"/>
+          </a:xfrm>
+          <a:prstGeom prst="rect">
+            <a:avLst/>
+          </a:prstGeom>
+          <a:noFill/>
+          <a:ln/>
+        </p:spPr>
+        <p:txBody>
+          <a:bodyPr wrap="square" rtlCol="0" anchor="ctr"/>
+          <a:lstStyle/>
+          <a:p>
+            <a:pPr marL="0" indent="0" algn="l">
+              <a:buNone/>
+            </a:pPr>
+            <a:r>
+              <a:rPr lang="en-US" sz="2600" b="1">
+                <a:solidFill>
+                  <a:srgbClr val="024879"/>
+                </a:solidFill>
+                <a:latin typeface="Arial" pitchFamily="34" charset="0"/>
+                <a:ea typeface="Arial" pitchFamily="34" charset="-122"/>
+                <a:cs typeface="Arial" pitchFamily="34" charset="-120"/>
+              </a:rPr>
+              <a:t>The Rubric — 5 Topics</a:t>
+            </a:r>
+            <a:endParaRPr lang="en-US" sz="2600"/>
+          </a:p>
+        </p:txBody>
+      </p:sp>
+      <p:pic>
+        <p:nvPicPr>
+          <p:cNvPr id="3" name="Image 0" descr="preencoded.png"/>
+          <p:cNvPicPr>
+            <a:picLocks noChangeAspect="1"/>
+          </p:cNvPicPr>
+          <p:nvPr/>
+        </p:nvPicPr>
+        <p:blipFill>
+          <a:blip r:embed="rId3"/>
+          <a:stretch>
+            <a:fillRect/>
+          </a:stretch>
+        </p:blipFill>
+        <p:spPr>
+          <a:xfrm>
+            <a:off x="7818120" y="292608"/>
+            <a:ext cx="914400" cy="274730"/>
+          </a:xfrm>
+          <a:prstGeom prst="rect">
+            <a:avLst/>
+          </a:prstGeom>
+        </p:spPr>
+      </p:pic>
+      <p:sp>
+        <p:nvSpPr>
+          <p:cNvPr id="4" name="Text 1"/>
+          <p:cNvSpPr/>
+          <p:nvPr/>
+        </p:nvSpPr>
+        <p:spPr>
+          <a:xfrm>
+            <a:off x="457200" y="896112"/>
+            <a:ext cx="8229600" cy="274320"/>
+          </a:xfrm>
+          <a:prstGeom prst="rect">
+            <a:avLst/>
+          </a:prstGeom>
+          <a:noFill/>
+          <a:ln/>
+        </p:spPr>
+        <p:txBody>
+          <a:bodyPr wrap="square" rtlCol="0" anchor="ctr"/>
+          <a:lstStyle/>
+          <a:p>
+            <a:pPr marL="0" indent="0">
+              <a:buNone/>
+            </a:pPr>
+            <a:r>
+              <a:rPr lang="en-US" sz="1200" i="1">
+                <a:solidFill>
+                  <a:srgbClr val="5A6B72"/>
+                </a:solidFill>
+                <a:latin typeface="Calibri" pitchFamily="34" charset="0"/>
+                <a:ea typeface="Calibri" pitchFamily="34" charset="-122"/>
+                <a:cs typeface="Calibri" pitchFamily="34" charset="-120"/>
+              </a:rPr>
+              <a:t>Each topic scored 0–30. Demonstrate at least 3. Clear at 70 / 150.</a:t>
+            </a:r>
+            <a:endParaRPr lang="en-US" sz="1200"/>
+          </a:p>
+        </p:txBody>
+      </p:sp>
+      <p:graphicFrame>
+        <p:nvGraphicFramePr>
+          <p:cNvPr id="11" name="Table 0"/>
+          <p:cNvGraphicFramePr>
+            <a:graphicFrameLocks noGrp="1"/>
+          </p:cNvGraphicFramePr>
+          <p:nvPr>
+            <p:extLst>
+              <p:ext uri="{D42A27DB-BD31-4B8C-83A1-F6EECF244321}">
+                <p14:modId xmlns:p14="http://schemas.microsoft.com/office/powerpoint/2010/main" val="1579011935"/>
+              </p:ext>
+            </p:extLst>
+          </p:nvPr>
+        </p:nvGraphicFramePr>
+        <p:xfrm>
+          <a:off x="457200" y="1234440"/>
+          <a:ext cx="8229600" cy="3200400"/>
+        </p:xfrm>
+        <a:graphic>
+          <a:graphicData uri="http://schemas.openxmlformats.org/drawingml/2006/table">
+            <a:tbl>
+              <a:tblPr/>
+              <a:tblGrid>
+                <a:gridCol w="2468880">
+                  <a:extLst>
+                    <a:ext uri="{9D8B030D-6E8A-4147-A177-3AD203B41FA5}">
+                      <a16:colId xmlns:a16="http://schemas.microsoft.com/office/drawing/2014/main" val="20000"/>
+                    </a:ext>
+                  </a:extLst>
+                </a:gridCol>
+                <a:gridCol w="5029200">
+                  <a:extLst>
+                    <a:ext uri="{9D8B030D-6E8A-4147-A177-3AD203B41FA5}">
+                      <a16:colId xmlns:a16="http://schemas.microsoft.com/office/drawing/2014/main" val="20001"/>
+                    </a:ext>
+                  </a:extLst>
+                </a:gridCol>
+                <a:gridCol w="731520">
+                  <a:extLst>
+                    <a:ext uri="{9D8B030D-6E8A-4147-A177-3AD203B41FA5}">
+                      <a16:colId xmlns:a16="http://schemas.microsoft.com/office/drawing/2014/main" val="20002"/>
+                    </a:ext>
+                  </a:extLst>
+                </a:gridCol>
+              </a:tblGrid>
+              <a:tr h="365760">
+                <a:tc>
+                  <a:txBody>
+                    <a:bodyPr/>
+                    <a:lstStyle/>
+                    <a:p>
+                      <a:pPr marL="0" indent="0">
+                        <a:buNone/>
+                      </a:pPr>
+                      <a:r>
+                        <a:rPr lang="en-US" sz="1100" b="1">
+                          <a:solidFill>
+                            <a:srgbClr val="FFFFFF"/>
+                          </a:solidFill>
+                          <a:latin typeface="Calibri" pitchFamily="34" charset="0"/>
+                          <a:ea typeface="Calibri" pitchFamily="34" charset="-122"/>
+                          <a:cs typeface="Calibri" pitchFamily="34" charset="-120"/>
+                        </a:rPr>
+                        <a:t>Competency topic</a:t>
+                      </a:r>
+                      <a:endParaRPr lang="en-US" sz="1100">
+                        <a:latin typeface="Calibri" charset="0"/>
+                        <a:ea typeface="Calibri" charset="0"/>
+                        <a:cs typeface="Calibri" charset="0"/>
+                      </a:endParaRPr>
+                    </a:p>
+                  </a:txBody>
+                  <a:tcPr anchor="ctr">
+                    <a:lnL w="6350" cap="flat" cmpd="sng" algn="ctr">
+                      <a:solidFill>
+                        <a:srgbClr val="B7C4CC"/>
+                      </a:solidFill>
+                      <a:prstDash val="solid"/>
+                      <a:round/>
+                      <a:headEnd type="none" w="med" len="med"/>
+                      <a:tailEnd type="none" w="med" len="med"/>
+                    </a:lnL>
+                    <a:lnR w="6350" cap="flat" cmpd="sng" algn="ctr">
+                      <a:solidFill>
+                        <a:srgbClr val="B7C4CC"/>
+                      </a:solidFill>
+                      <a:prstDash val="solid"/>
+                      <a:round/>
+                      <a:headEnd type="none" w="med" len="med"/>
+                      <a:tailEnd type="none" w="med" len="med"/>
+                    </a:lnR>
+                    <a:lnT w="6350" cap="flat" cmpd="sng" algn="ctr">
+                      <a:solidFill>
+                        <a:srgbClr val="B7C4CC"/>
+                      </a:solidFill>
+                      <a:prstDash val="solid"/>
+                      <a:round/>
+                      <a:headEnd type="none" w="med" len="med"/>
+                      <a:tailEnd type="none" w="med" len="med"/>
+                    </a:lnT>
+                    <a:lnB w="6350" cap="flat" cmpd="sng" algn="ctr">
+                      <a:solidFill>
+                        <a:srgbClr val="B7C4CC"/>
+                      </a:solidFill>
+                      <a:prstDash val="solid"/>
+                      <a:round/>
+                      <a:headEnd type="none" w="med" len="med"/>
+                      <a:tailEnd type="none" w="med" len="med"/>
+                    </a:lnB>
+                    <a:solidFill>
+                      <a:srgbClr val="075056"/>
+                    </a:solidFill>
+                  </a:tcPr>
+                </a:tc>
+                <a:tc>
+                  <a:txBody>
+                    <a:bodyPr/>
+                    <a:lstStyle/>
+                    <a:p>
+                      <a:pPr marL="0" indent="0">
+                        <a:buNone/>
+                      </a:pPr>
+                      <a:r>
+                        <a:rPr lang="en-US" sz="1100" b="1">
+                          <a:solidFill>
+                            <a:srgbClr val="FFFFFF"/>
+                          </a:solidFill>
+                          <a:latin typeface="Calibri" pitchFamily="34" charset="0"/>
+                          <a:ea typeface="Calibri" pitchFamily="34" charset="-122"/>
+                          <a:cs typeface="Calibri" pitchFamily="34" charset="-120"/>
+                        </a:rPr>
+                        <a:t>What earns top marks (25–30)</a:t>
+                      </a:r>
+                      <a:endParaRPr lang="en-US" sz="1100">
+                        <a:latin typeface="Calibri" charset="0"/>
+                        <a:ea typeface="Calibri" charset="0"/>
+                        <a:cs typeface="Calibri" charset="0"/>
+                      </a:endParaRPr>
+                    </a:p>
+                  </a:txBody>
+                  <a:tcPr anchor="ctr">
+                    <a:lnL w="6350" cap="flat" cmpd="sng" algn="ctr">
+                      <a:solidFill>
+                        <a:srgbClr val="B7C4CC"/>
+                      </a:solidFill>
+                      <a:prstDash val="solid"/>
+                      <a:round/>
+                      <a:headEnd type="none" w="med" len="med"/>
+                      <a:tailEnd type="none" w="med" len="med"/>
+                    </a:lnL>
+                    <a:lnR w="6350" cap="flat" cmpd="sng" algn="ctr">
+                      <a:solidFill>
+                        <a:srgbClr val="B7C4CC"/>
+                      </a:solidFill>
+                      <a:prstDash val="solid"/>
+                      <a:round/>
+                      <a:headEnd type="none" w="med" len="med"/>
+                      <a:tailEnd type="none" w="med" len="med"/>
+                    </a:lnR>
+                    <a:lnT w="6350" cap="flat" cmpd="sng" algn="ctr">
+                      <a:solidFill>
+                        <a:srgbClr val="B7C4CC"/>
+                      </a:solidFill>
+                      <a:prstDash val="solid"/>
+                      <a:round/>
+                      <a:headEnd type="none" w="med" len="med"/>
+                      <a:tailEnd type="none" w="med" len="med"/>
+                    </a:lnT>
+                    <a:lnB w="6350" cap="flat" cmpd="sng" algn="ctr">
+                      <a:solidFill>
+                        <a:srgbClr val="B7C4CC"/>
+                      </a:solidFill>
+                      <a:prstDash val="solid"/>
+                      <a:round/>
+                      <a:headEnd type="none" w="med" len="med"/>
+                      <a:tailEnd type="none" w="med" len="med"/>
+                    </a:lnB>
+                    <a:solidFill>
+                      <a:srgbClr val="075056"/>
+                    </a:solidFill>
+                  </a:tcPr>
+                </a:tc>
+                <a:tc>
+                  <a:txBody>
+                    <a:bodyPr/>
+                    <a:lstStyle/>
+                    <a:p>
+                      <a:pPr marL="0" indent="0" algn="ctr">
+                        <a:buNone/>
+                      </a:pPr>
+                      <a:r>
+                        <a:rPr lang="en-US" sz="1100" b="1">
+                          <a:solidFill>
+                            <a:srgbClr val="FFFFFF"/>
+                          </a:solidFill>
+                          <a:latin typeface="Calibri" pitchFamily="34" charset="0"/>
+                          <a:ea typeface="Calibri" pitchFamily="34" charset="-122"/>
+                          <a:cs typeface="Calibri" pitchFamily="34" charset="-120"/>
+                        </a:rPr>
+                        <a:t>Max</a:t>
+                      </a:r>
+                      <a:endParaRPr lang="en-US" sz="1100">
+                        <a:latin typeface="Calibri" charset="0"/>
+                        <a:ea typeface="Calibri" charset="0"/>
+                        <a:cs typeface="Calibri" charset="0"/>
+                      </a:endParaRPr>
+                    </a:p>
+                  </a:txBody>
+                  <a:tcPr anchor="ctr">
+                    <a:lnL w="6350" cap="flat" cmpd="sng" algn="ctr">
+                      <a:solidFill>
+                        <a:srgbClr val="B7C4CC"/>
+                      </a:solidFill>
+                      <a:prstDash val="solid"/>
+                      <a:round/>
+                      <a:headEnd type="none" w="med" len="med"/>
+                      <a:tailEnd type="none" w="med" len="med"/>
+                    </a:lnL>
+                    <a:lnR w="6350" cap="flat" cmpd="sng" algn="ctr">
+                      <a:solidFill>
+                        <a:srgbClr val="B7C4CC"/>
+                      </a:solidFill>
+                      <a:prstDash val="solid"/>
+                      <a:round/>
+                      <a:headEnd type="none" w="med" len="med"/>
+                      <a:tailEnd type="none" w="med" len="med"/>
+                    </a:lnR>
+                    <a:lnT w="6350" cap="flat" cmpd="sng" algn="ctr">
+                      <a:solidFill>
+                        <a:srgbClr val="B7C4CC"/>
+                      </a:solidFill>
+                      <a:prstDash val="solid"/>
+                      <a:round/>
+                      <a:headEnd type="none" w="med" len="med"/>
+                      <a:tailEnd type="none" w="med" len="med"/>
+                    </a:lnT>
+                    <a:lnB w="6350" cap="flat" cmpd="sng" algn="ctr">
+                      <a:solidFill>
+                        <a:srgbClr val="B7C4CC"/>
+                      </a:solidFill>
+                      <a:prstDash val="solid"/>
+                      <a:round/>
+                      <a:headEnd type="none" w="med" len="med"/>
+                      <a:tailEnd type="none" w="med" len="med"/>
+                    </a:lnB>
+                    <a:solidFill>
+                      <a:srgbClr val="075056"/>
+                    </a:solidFill>
+                  </a:tcPr>
+                </a:tc>
+                <a:extLst>
+                  <a:ext uri="{0D108BD9-81ED-4DB2-BD59-A6C34878D82A}">
+                    <a16:rowId xmlns:a16="http://schemas.microsoft.com/office/drawing/2014/main" val="10000"/>
+                  </a:ext>
+                </a:extLst>
+              </a:tr>
+              <a:tr h="566928">
+                <a:tc>
+                  <a:txBody>
+                    <a:bodyPr/>
+                    <a:lstStyle/>
+                    <a:p>
+                      <a:pPr marL="0" indent="0">
+                        <a:buNone/>
+                      </a:pPr>
+                      <a:r>
+                        <a:rPr lang="en-US" sz="1100" b="1">
+                          <a:solidFill>
+                            <a:srgbClr val="024879"/>
+                          </a:solidFill>
+                          <a:latin typeface="Calibri" pitchFamily="34" charset="0"/>
+                          <a:ea typeface="Calibri" pitchFamily="34" charset="-122"/>
+                          <a:cs typeface="Calibri" pitchFamily="34" charset="-120"/>
+                        </a:rPr>
+                        <a:t>Spec-Driven Development</a:t>
+                      </a:r>
+                      <a:endParaRPr lang="en-US" sz="1100">
+                        <a:latin typeface="Calibri" charset="0"/>
+                        <a:ea typeface="Calibri" charset="0"/>
+                        <a:cs typeface="Calibri" charset="0"/>
+                      </a:endParaRPr>
+                    </a:p>
+                  </a:txBody>
+                  <a:tcPr anchor="ctr">
+                    <a:lnL w="6350" cap="flat" cmpd="sng" algn="ctr">
+                      <a:solidFill>
+                        <a:srgbClr val="B7C4CC"/>
+                      </a:solidFill>
+                      <a:prstDash val="solid"/>
+                      <a:round/>
+                      <a:headEnd type="none" w="med" len="med"/>
+                      <a:tailEnd type="none" w="med" len="med"/>
+                    </a:lnL>
+                    <a:lnR w="6350" cap="flat" cmpd="sng" algn="ctr">
+                      <a:solidFill>
+                        <a:srgbClr val="B7C4CC"/>
+                      </a:solidFill>
+                      <a:prstDash val="solid"/>
+                      <a:round/>
+                      <a:headEnd type="none" w="med" len="med"/>
+                      <a:tailEnd type="none" w="med" len="med"/>
+                    </a:lnR>
+                    <a:lnT w="6350" cap="flat" cmpd="sng" algn="ctr">
+                      <a:solidFill>
+                        <a:srgbClr val="B7C4CC"/>
+                      </a:solidFill>
+                      <a:prstDash val="solid"/>
+                      <a:round/>
+                      <a:headEnd type="none" w="med" len="med"/>
+                      <a:tailEnd type="none" w="med" len="med"/>
+                    </a:lnT>
+                    <a:lnB w="6350" cap="flat" cmpd="sng" algn="ctr">
+                      <a:solidFill>
+                        <a:srgbClr val="B7C4CC"/>
+                      </a:solidFill>
+                      <a:prstDash val="solid"/>
+                      <a:round/>
+                      <a:headEnd type="none" w="med" len="med"/>
+                      <a:tailEnd type="none" w="med" len="med"/>
+                    </a:lnB>
+                    <a:solidFill>
+                      <a:srgbClr val="DFE7ED"/>
+                    </a:solidFill>
+                  </a:tcPr>
+                </a:tc>
+                <a:tc>
+                  <a:txBody>
+                    <a:bodyPr/>
+                    <a:lstStyle/>
+                    <a:p>
+                      <a:pPr marL="0" indent="0">
+                        <a:buNone/>
+                      </a:pPr>
+                      <a:r>
+                        <a:rPr lang="en-US" sz="1100">
+                          <a:solidFill>
+                            <a:srgbClr val="1B2227"/>
+                          </a:solidFill>
+                          <a:latin typeface="Calibri" pitchFamily="34" charset="0"/>
+                          <a:ea typeface="Calibri" pitchFamily="34" charset="-122"/>
+                          <a:cs typeface="Calibri" pitchFamily="34" charset="-120"/>
+                        </a:rPr>
+                        <a:t>Spec discipline governs agent behaviour and hand-offs, not just a single file.</a:t>
+                      </a:r>
+                      <a:endParaRPr lang="en-US" sz="1100">
+                        <a:latin typeface="Calibri" charset="0"/>
+                        <a:ea typeface="Calibri" charset="0"/>
+                        <a:cs typeface="Calibri" charset="0"/>
+                      </a:endParaRPr>
+                    </a:p>
+                  </a:txBody>
+                  <a:tcPr anchor="ctr">
+                    <a:lnL w="6350" cap="flat" cmpd="sng" algn="ctr">
+                      <a:solidFill>
+                        <a:srgbClr val="B7C4CC"/>
+                      </a:solidFill>
+                      <a:prstDash val="solid"/>
+                      <a:round/>
+                      <a:headEnd type="none" w="med" len="med"/>
+                      <a:tailEnd type="none" w="med" len="med"/>
+                    </a:lnL>
+                    <a:lnR w="6350" cap="flat" cmpd="sng" algn="ctr">
+                      <a:solidFill>
+                        <a:srgbClr val="B7C4CC"/>
+                      </a:solidFill>
+                      <a:prstDash val="solid"/>
+                      <a:round/>
+                      <a:headEnd type="none" w="med" len="med"/>
+                      <a:tailEnd type="none" w="med" len="med"/>
+                    </a:lnR>
+                    <a:lnT w="6350" cap="flat" cmpd="sng" algn="ctr">
+                      <a:solidFill>
+                        <a:srgbClr val="B7C4CC"/>
+                      </a:solidFill>
+                      <a:prstDash val="solid"/>
+                      <a:round/>
+                      <a:headEnd type="none" w="med" len="med"/>
+                      <a:tailEnd type="none" w="med" len="med"/>
+                    </a:lnT>
+                    <a:lnB w="6350" cap="flat" cmpd="sng" algn="ctr">
+                      <a:solidFill>
+                        <a:srgbClr val="B7C4CC"/>
+                      </a:solidFill>
+                      <a:prstDash val="solid"/>
+                      <a:round/>
+                      <a:headEnd type="none" w="med" len="med"/>
+                      <a:tailEnd type="none" w="med" len="med"/>
+                    </a:lnB>
+                    <a:solidFill>
+                      <a:srgbClr val="DFE7ED"/>
+                    </a:solidFill>
+                  </a:tcPr>
+                </a:tc>
+                <a:tc>
+                  <a:txBody>
+                    <a:bodyPr/>
+                    <a:lstStyle/>
+                    <a:p>
+                      <a:pPr marL="0" indent="0" algn="ctr">
+                        <a:buNone/>
+                      </a:pPr>
+                      <a:r>
+                        <a:rPr lang="en-US" sz="1100" b="1">
+                          <a:solidFill>
+                            <a:srgbClr val="1B2227"/>
+                          </a:solidFill>
+                          <a:latin typeface="Calibri" pitchFamily="34" charset="0"/>
+                          <a:ea typeface="Calibri" pitchFamily="34" charset="-122"/>
+                          <a:cs typeface="Calibri" pitchFamily="34" charset="-120"/>
+                        </a:rPr>
+                        <a:t>30</a:t>
+                      </a:r>
+                      <a:endParaRPr lang="en-US" sz="1100">
+                        <a:latin typeface="Calibri" charset="0"/>
+                        <a:ea typeface="Calibri" charset="0"/>
+                        <a:cs typeface="Calibri" charset="0"/>
+                      </a:endParaRPr>
+                    </a:p>
+                  </a:txBody>
+                  <a:tcPr anchor="ctr">
+                    <a:lnL w="6350" cap="flat" cmpd="sng" algn="ctr">
+                      <a:solidFill>
+                        <a:srgbClr val="B7C4CC"/>
+                      </a:solidFill>
+                      <a:prstDash val="solid"/>
+                      <a:round/>
+                      <a:headEnd type="none" w="med" len="med"/>
+                      <a:tailEnd type="none" w="med" len="med"/>
+                    </a:lnL>
+                    <a:lnR w="6350" cap="flat" cmpd="sng" algn="ctr">
+                      <a:solidFill>
+                        <a:srgbClr val="B7C4CC"/>
+                      </a:solidFill>
+                      <a:prstDash val="solid"/>
+                      <a:round/>
+                      <a:headEnd type="none" w="med" len="med"/>
+                      <a:tailEnd type="none" w="med" len="med"/>
+                    </a:lnR>
+                    <a:lnT w="6350" cap="flat" cmpd="sng" algn="ctr">
+                      <a:solidFill>
+                        <a:srgbClr val="B7C4CC"/>
+                      </a:solidFill>
+                      <a:prstDash val="solid"/>
+                      <a:round/>
+                      <a:headEnd type="none" w="med" len="med"/>
+                      <a:tailEnd type="none" w="med" len="med"/>
+                    </a:lnT>
+                    <a:lnB w="6350" cap="flat" cmpd="sng" algn="ctr">
+                      <a:solidFill>
+                        <a:srgbClr val="B7C4CC"/>
+                      </a:solidFill>
+                      <a:prstDash val="solid"/>
+                      <a:round/>
+                      <a:headEnd type="none" w="med" len="med"/>
+                      <a:tailEnd type="none" w="med" len="med"/>
+                    </a:lnB>
+                    <a:solidFill>
+                      <a:srgbClr val="DFE7ED"/>
+                    </a:solidFill>
+                  </a:tcPr>
+                </a:tc>
+                <a:extLst>
+                  <a:ext uri="{0D108BD9-81ED-4DB2-BD59-A6C34878D82A}">
+                    <a16:rowId xmlns:a16="http://schemas.microsoft.com/office/drawing/2014/main" val="10001"/>
+                  </a:ext>
+                </a:extLst>
+              </a:tr>
+              <a:tr h="566928">
+                <a:tc>
+                  <a:txBody>
+                    <a:bodyPr/>
+                    <a:lstStyle/>
+                    <a:p>
+                      <a:pPr marL="0" indent="0">
+                        <a:buNone/>
+                      </a:pPr>
+                      <a:r>
+                        <a:rPr lang="en-US" sz="1100" b="1">
+                          <a:solidFill>
+                            <a:srgbClr val="024879"/>
+                          </a:solidFill>
+                          <a:latin typeface="Calibri" pitchFamily="34" charset="0"/>
+                          <a:ea typeface="Calibri" pitchFamily="34" charset="-122"/>
+                          <a:cs typeface="Calibri" pitchFamily="34" charset="-120"/>
+                        </a:rPr>
+                        <a:t>AI-Powered Development</a:t>
+                      </a:r>
+                      <a:endParaRPr lang="en-US" sz="1100">
+                        <a:latin typeface="Calibri" charset="0"/>
+                        <a:ea typeface="Calibri" charset="0"/>
+                        <a:cs typeface="Calibri" charset="0"/>
+                      </a:endParaRPr>
+                    </a:p>
+                  </a:txBody>
+                  <a:tcPr anchor="ctr">
+                    <a:lnL w="6350" cap="flat" cmpd="sng" algn="ctr">
+                      <a:solidFill>
+                        <a:srgbClr val="B7C4CC"/>
+                      </a:solidFill>
+                      <a:prstDash val="solid"/>
+                      <a:round/>
+                      <a:headEnd type="none" w="med" len="med"/>
+                      <a:tailEnd type="none" w="med" len="med"/>
+                    </a:lnL>
+                    <a:lnR w="6350" cap="flat" cmpd="sng" algn="ctr">
+                      <a:solidFill>
+                        <a:srgbClr val="B7C4CC"/>
+                      </a:solidFill>
+                      <a:prstDash val="solid"/>
+                      <a:round/>
+                      <a:headEnd type="none" w="med" len="med"/>
+                      <a:tailEnd type="none" w="med" len="med"/>
+                    </a:lnR>
+                    <a:lnT w="6350" cap="flat" cmpd="sng" algn="ctr">
+                      <a:solidFill>
+                        <a:srgbClr val="B7C4CC"/>
+                      </a:solidFill>
+                      <a:prstDash val="solid"/>
+                      <a:round/>
+                      <a:headEnd type="none" w="med" len="med"/>
+                      <a:tailEnd type="none" w="med" len="med"/>
+                    </a:lnT>
+                    <a:lnB w="6350" cap="flat" cmpd="sng" algn="ctr">
+                      <a:solidFill>
+                        <a:srgbClr val="B7C4CC"/>
+                      </a:solidFill>
+                      <a:prstDash val="solid"/>
+                      <a:round/>
+                      <a:headEnd type="none" w="med" len="med"/>
+                      <a:tailEnd type="none" w="med" len="med"/>
+                    </a:lnB>
+                    <a:solidFill>
+                      <a:srgbClr val="FFFFFF"/>
+                    </a:solidFill>
+                  </a:tcPr>
+                </a:tc>
+                <a:tc>
+                  <a:txBody>
+                    <a:bodyPr/>
+                    <a:lstStyle/>
+                    <a:p>
+                      <a:pPr marL="0" indent="0">
+                        <a:buNone/>
+                      </a:pPr>
+                      <a:r>
+                        <a:rPr lang="en-US" sz="1100">
+                          <a:solidFill>
+                            <a:srgbClr val="1B2227"/>
+                          </a:solidFill>
+                          <a:latin typeface="Calibri" pitchFamily="34" charset="0"/>
+                          <a:ea typeface="Calibri" pitchFamily="34" charset="-122"/>
+                          <a:cs typeface="Calibri" pitchFamily="34" charset="-120"/>
+                        </a:rPr>
+                        <a:t>Advanced Claude Code / Copilot (agent modes, CLI, skills) delivering working software.</a:t>
+                      </a:r>
+                      <a:endParaRPr lang="en-US" sz="1100">
+                        <a:latin typeface="Calibri" charset="0"/>
+                        <a:ea typeface="Calibri" charset="0"/>
+                        <a:cs typeface="Calibri" charset="0"/>
+                      </a:endParaRPr>
+                    </a:p>
+                  </a:txBody>
+                  <a:tcPr anchor="ctr">
+                    <a:lnL w="6350" cap="flat" cmpd="sng" algn="ctr">
+                      <a:solidFill>
+                        <a:srgbClr val="B7C4CC"/>
+                      </a:solidFill>
+                      <a:prstDash val="solid"/>
+                      <a:round/>
+                      <a:headEnd type="none" w="med" len="med"/>
+                      <a:tailEnd type="none" w="med" len="med"/>
+                    </a:lnL>
+                    <a:lnR w="6350" cap="flat" cmpd="sng" algn="ctr">
+                      <a:solidFill>
+                        <a:srgbClr val="B7C4CC"/>
+                      </a:solidFill>
+                      <a:prstDash val="solid"/>
+                      <a:round/>
+                      <a:headEnd type="none" w="med" len="med"/>
+                      <a:tailEnd type="none" w="med" len="med"/>
+                    </a:lnR>
+                    <a:lnT w="6350" cap="flat" cmpd="sng" algn="ctr">
+                      <a:solidFill>
+                        <a:srgbClr val="B7C4CC"/>
+                      </a:solidFill>
+                      <a:prstDash val="solid"/>
+                      <a:round/>
+                      <a:headEnd type="none" w="med" len="med"/>
+                      <a:tailEnd type="none" w="med" len="med"/>
+                    </a:lnT>
+                    <a:lnB w="6350" cap="flat" cmpd="sng" algn="ctr">
+                      <a:solidFill>
+                        <a:srgbClr val="B7C4CC"/>
+                      </a:solidFill>
+                      <a:prstDash val="solid"/>
+                      <a:round/>
+                      <a:headEnd type="none" w="med" len="med"/>
+                      <a:tailEnd type="none" w="med" len="med"/>
+                    </a:lnB>
+                    <a:solidFill>
+                      <a:srgbClr val="FFFFFF"/>
+                    </a:solidFill>
+                  </a:tcPr>
+                </a:tc>
+                <a:tc>
+                  <a:txBody>
+                    <a:bodyPr/>
+                    <a:lstStyle/>
+                    <a:p>
+                      <a:pPr marL="0" indent="0" algn="ctr">
+                        <a:buNone/>
+                      </a:pPr>
+                      <a:r>
+                        <a:rPr lang="en-US" sz="1100" b="1">
+                          <a:solidFill>
+                            <a:srgbClr val="1B2227"/>
+                          </a:solidFill>
+                          <a:latin typeface="Calibri" pitchFamily="34" charset="0"/>
+                          <a:ea typeface="Calibri" pitchFamily="34" charset="-122"/>
+                          <a:cs typeface="Calibri" pitchFamily="34" charset="-120"/>
+                        </a:rPr>
+                        <a:t>30</a:t>
+                      </a:r>
+                      <a:endParaRPr lang="en-US" sz="1100">
+                        <a:latin typeface="Calibri" charset="0"/>
+                        <a:ea typeface="Calibri" charset="0"/>
+                        <a:cs typeface="Calibri" charset="0"/>
+                      </a:endParaRPr>
+                    </a:p>
+                  </a:txBody>
+                  <a:tcPr anchor="ctr">
+                    <a:lnL w="6350" cap="flat" cmpd="sng" algn="ctr">
+                      <a:solidFill>
+                        <a:srgbClr val="B7C4CC"/>
+                      </a:solidFill>
+                      <a:prstDash val="solid"/>
+                      <a:round/>
+                      <a:headEnd type="none" w="med" len="med"/>
+                      <a:tailEnd type="none" w="med" len="med"/>
+                    </a:lnL>
+                    <a:lnR w="6350" cap="flat" cmpd="sng" algn="ctr">
+                      <a:solidFill>
+                        <a:srgbClr val="B7C4CC"/>
+                      </a:solidFill>
+                      <a:prstDash val="solid"/>
+                      <a:round/>
+                      <a:headEnd type="none" w="med" len="med"/>
+                      <a:tailEnd type="none" w="med" len="med"/>
+                    </a:lnR>
+                    <a:lnT w="6350" cap="flat" cmpd="sng" algn="ctr">
+                      <a:solidFill>
+                        <a:srgbClr val="B7C4CC"/>
+                      </a:solidFill>
+                      <a:prstDash val="solid"/>
+                      <a:round/>
+                      <a:headEnd type="none" w="med" len="med"/>
+                      <a:tailEnd type="none" w="med" len="med"/>
+                    </a:lnT>
+                    <a:lnB w="6350" cap="flat" cmpd="sng" algn="ctr">
+                      <a:solidFill>
+                        <a:srgbClr val="B7C4CC"/>
+                      </a:solidFill>
+                      <a:prstDash val="solid"/>
+                      <a:round/>
+                      <a:headEnd type="none" w="med" len="med"/>
+                      <a:tailEnd type="none" w="med" len="med"/>
+                    </a:lnB>
+                    <a:solidFill>
+                      <a:srgbClr val="FFFFFF"/>
+                    </a:solidFill>
+                  </a:tcPr>
+                </a:tc>
+                <a:extLst>
+                  <a:ext uri="{0D108BD9-81ED-4DB2-BD59-A6C34878D82A}">
+                    <a16:rowId xmlns:a16="http://schemas.microsoft.com/office/drawing/2014/main" val="10002"/>
+                  </a:ext>
+                </a:extLst>
+              </a:tr>
+              <a:tr h="566928">
+                <a:tc>
+                  <a:txBody>
+                    <a:bodyPr/>
+                    <a:lstStyle/>
+                    <a:p>
+                      <a:pPr marL="0" indent="0">
+                        <a:buNone/>
+                      </a:pPr>
+                      <a:r>
+                        <a:rPr lang="en-US" sz="1100" b="1">
+                          <a:solidFill>
+                            <a:srgbClr val="024879"/>
+                          </a:solidFill>
+                          <a:latin typeface="Calibri" pitchFamily="34" charset="0"/>
+                          <a:ea typeface="Calibri" pitchFamily="34" charset="-122"/>
+                          <a:cs typeface="Calibri" pitchFamily="34" charset="-120"/>
+                        </a:rPr>
+                        <a:t>LLM Evaluation &amp; Interpretability</a:t>
+                      </a:r>
+                      <a:endParaRPr lang="en-US" sz="1100">
+                        <a:latin typeface="Calibri" charset="0"/>
+                        <a:ea typeface="Calibri" charset="0"/>
+                        <a:cs typeface="Calibri" charset="0"/>
+                      </a:endParaRPr>
+                    </a:p>
+                  </a:txBody>
+                  <a:tcPr anchor="ctr">
+                    <a:lnL w="6350" cap="flat" cmpd="sng" algn="ctr">
+                      <a:solidFill>
+                        <a:srgbClr val="B7C4CC"/>
+                      </a:solidFill>
+                      <a:prstDash val="solid"/>
+                      <a:round/>
+                      <a:headEnd type="none" w="med" len="med"/>
+                      <a:tailEnd type="none" w="med" len="med"/>
+                    </a:lnL>
+                    <a:lnR w="6350" cap="flat" cmpd="sng" algn="ctr">
+                      <a:solidFill>
+                        <a:srgbClr val="B7C4CC"/>
+                      </a:solidFill>
+                      <a:prstDash val="solid"/>
+                      <a:round/>
+                      <a:headEnd type="none" w="med" len="med"/>
+                      <a:tailEnd type="none" w="med" len="med"/>
+                    </a:lnR>
+                    <a:lnT w="6350" cap="flat" cmpd="sng" algn="ctr">
+                      <a:solidFill>
+                        <a:srgbClr val="B7C4CC"/>
+                      </a:solidFill>
+                      <a:prstDash val="solid"/>
+                      <a:round/>
+                      <a:headEnd type="none" w="med" len="med"/>
+                      <a:tailEnd type="none" w="med" len="med"/>
+                    </a:lnT>
+                    <a:lnB w="6350" cap="flat" cmpd="sng" algn="ctr">
+                      <a:solidFill>
+                        <a:srgbClr val="B7C4CC"/>
+                      </a:solidFill>
+                      <a:prstDash val="solid"/>
+                      <a:round/>
+                      <a:headEnd type="none" w="med" len="med"/>
+                      <a:tailEnd type="none" w="med" len="med"/>
+                    </a:lnB>
+                    <a:solidFill>
+                      <a:srgbClr val="DFE7ED"/>
+                    </a:solidFill>
+                  </a:tcPr>
+                </a:tc>
+                <a:tc>
+                  <a:txBody>
+                    <a:bodyPr/>
+                    <a:lstStyle/>
+                    <a:p>
+                      <a:pPr marL="0" indent="0">
+                        <a:buNone/>
+                      </a:pPr>
+                      <a:r>
+                        <a:rPr lang="en-US" sz="1100">
+                          <a:solidFill>
+                            <a:srgbClr val="1B2227"/>
+                          </a:solidFill>
+                          <a:latin typeface="Calibri" pitchFamily="34" charset="0"/>
+                          <a:ea typeface="Calibri" pitchFamily="34" charset="-122"/>
+                          <a:cs typeface="Calibri" pitchFamily="34" charset="-120"/>
+                        </a:rPr>
+                        <a:t>Objective evaluation (LLM-as-judge, scored comparisons); data-grounded decisions.</a:t>
+                      </a:r>
+                      <a:endParaRPr lang="en-US" sz="1100">
+                        <a:latin typeface="Calibri" charset="0"/>
+                        <a:ea typeface="Calibri" charset="0"/>
+                        <a:cs typeface="Calibri" charset="0"/>
+                      </a:endParaRPr>
+                    </a:p>
+                  </a:txBody>
+                  <a:tcPr anchor="ctr">
+                    <a:lnL w="6350" cap="flat" cmpd="sng" algn="ctr">
+                      <a:solidFill>
+                        <a:srgbClr val="B7C4CC"/>
+                      </a:solidFill>
+                      <a:prstDash val="solid"/>
+                      <a:round/>
+                      <a:headEnd type="none" w="med" len="med"/>
+                      <a:tailEnd type="none" w="med" len="med"/>
+                    </a:lnL>
+                    <a:lnR w="6350" cap="flat" cmpd="sng" algn="ctr">
+                      <a:solidFill>
+                        <a:srgbClr val="B7C4CC"/>
+                      </a:solidFill>
+                      <a:prstDash val="solid"/>
+                      <a:round/>
+                      <a:headEnd type="none" w="med" len="med"/>
+                      <a:tailEnd type="none" w="med" len="med"/>
+                    </a:lnR>
+                    <a:lnT w="6350" cap="flat" cmpd="sng" algn="ctr">
+                      <a:solidFill>
+                        <a:srgbClr val="B7C4CC"/>
+                      </a:solidFill>
+                      <a:prstDash val="solid"/>
+                      <a:round/>
+                      <a:headEnd type="none" w="med" len="med"/>
+                      <a:tailEnd type="none" w="med" len="med"/>
+                    </a:lnT>
+                    <a:lnB w="6350" cap="flat" cmpd="sng" algn="ctr">
+                      <a:solidFill>
+                        <a:srgbClr val="B7C4CC"/>
+                      </a:solidFill>
+                      <a:prstDash val="solid"/>
+                      <a:round/>
+                      <a:headEnd type="none" w="med" len="med"/>
+                      <a:tailEnd type="none" w="med" len="med"/>
+                    </a:lnB>
+                    <a:solidFill>
+                      <a:srgbClr val="DFE7ED"/>
+                    </a:solidFill>
+                  </a:tcPr>
+                </a:tc>
+                <a:tc>
+                  <a:txBody>
+                    <a:bodyPr/>
+                    <a:lstStyle/>
+                    <a:p>
+                      <a:pPr marL="0" indent="0" algn="ctr">
+                        <a:buNone/>
+                      </a:pPr>
+                      <a:r>
+                        <a:rPr lang="en-US" sz="1100" b="1">
+                          <a:solidFill>
+                            <a:srgbClr val="1B2227"/>
+                          </a:solidFill>
+                          <a:latin typeface="Calibri" pitchFamily="34" charset="0"/>
+                          <a:ea typeface="Calibri" pitchFamily="34" charset="-122"/>
+                          <a:cs typeface="Calibri" pitchFamily="34" charset="-120"/>
+                        </a:rPr>
+                        <a:t>30</a:t>
+                      </a:r>
+                      <a:endParaRPr lang="en-US" sz="1100">
+                        <a:latin typeface="Calibri" charset="0"/>
+                        <a:ea typeface="Calibri" charset="0"/>
+                        <a:cs typeface="Calibri" charset="0"/>
+                      </a:endParaRPr>
+                    </a:p>
+                  </a:txBody>
+                  <a:tcPr anchor="ctr">
+                    <a:lnL w="6350" cap="flat" cmpd="sng" algn="ctr">
+                      <a:solidFill>
+                        <a:srgbClr val="B7C4CC"/>
+                      </a:solidFill>
+                      <a:prstDash val="solid"/>
+                      <a:round/>
+                      <a:headEnd type="none" w="med" len="med"/>
+                      <a:tailEnd type="none" w="med" len="med"/>
+                    </a:lnL>
+                    <a:lnR w="6350" cap="flat" cmpd="sng" algn="ctr">
+                      <a:solidFill>
+                        <a:srgbClr val="B7C4CC"/>
+                      </a:solidFill>
+                      <a:prstDash val="solid"/>
+                      <a:round/>
+                      <a:headEnd type="none" w="med" len="med"/>
+                      <a:tailEnd type="none" w="med" len="med"/>
+                    </a:lnR>
+                    <a:lnT w="6350" cap="flat" cmpd="sng" algn="ctr">
+                      <a:solidFill>
+                        <a:srgbClr val="B7C4CC"/>
+                      </a:solidFill>
+                      <a:prstDash val="solid"/>
+                      <a:round/>
+                      <a:headEnd type="none" w="med" len="med"/>
+                      <a:tailEnd type="none" w="med" len="med"/>
+                    </a:lnT>
+                    <a:lnB w="6350" cap="flat" cmpd="sng" algn="ctr">
+                      <a:solidFill>
+                        <a:srgbClr val="B7C4CC"/>
+                      </a:solidFill>
+                      <a:prstDash val="solid"/>
+                      <a:round/>
+                      <a:headEnd type="none" w="med" len="med"/>
+                      <a:tailEnd type="none" w="med" len="med"/>
+                    </a:lnB>
+                    <a:solidFill>
+                      <a:srgbClr val="DFE7ED"/>
+                    </a:solidFill>
+                  </a:tcPr>
+                </a:tc>
+                <a:extLst>
+                  <a:ext uri="{0D108BD9-81ED-4DB2-BD59-A6C34878D82A}">
+                    <a16:rowId xmlns:a16="http://schemas.microsoft.com/office/drawing/2014/main" val="10003"/>
+                  </a:ext>
+                </a:extLst>
+              </a:tr>
+              <a:tr h="566928">
+                <a:tc>
+                  <a:txBody>
+                    <a:bodyPr/>
+                    <a:lstStyle/>
+                    <a:p>
+                      <a:pPr marL="0" indent="0">
+                        <a:buNone/>
+                      </a:pPr>
+                      <a:r>
+                        <a:rPr lang="en-US" sz="1100" b="1">
+                          <a:solidFill>
+                            <a:srgbClr val="024879"/>
+                          </a:solidFill>
+                          <a:latin typeface="Calibri" pitchFamily="34" charset="0"/>
+                          <a:ea typeface="Calibri" pitchFamily="34" charset="-122"/>
+                          <a:cs typeface="Calibri" pitchFamily="34" charset="-120"/>
+                        </a:rPr>
+                        <a:t>Agent Design, Orchestration &amp; Ops</a:t>
+                      </a:r>
+                      <a:endParaRPr lang="en-US" sz="1100">
+                        <a:latin typeface="Calibri" charset="0"/>
+                        <a:ea typeface="Calibri" charset="0"/>
+                        <a:cs typeface="Calibri" charset="0"/>
+                      </a:endParaRPr>
+                    </a:p>
+                  </a:txBody>
+                  <a:tcPr anchor="ctr">
+                    <a:lnL w="6350" cap="flat" cmpd="sng" algn="ctr">
+                      <a:solidFill>
+                        <a:srgbClr val="B7C4CC"/>
+                      </a:solidFill>
+                      <a:prstDash val="solid"/>
+                      <a:round/>
+                      <a:headEnd type="none" w="med" len="med"/>
+                      <a:tailEnd type="none" w="med" len="med"/>
+                    </a:lnL>
+                    <a:lnR w="6350" cap="flat" cmpd="sng" algn="ctr">
+                      <a:solidFill>
+                        <a:srgbClr val="B7C4CC"/>
+                      </a:solidFill>
+                      <a:prstDash val="solid"/>
+                      <a:round/>
+                      <a:headEnd type="none" w="med" len="med"/>
+                      <a:tailEnd type="none" w="med" len="med"/>
+                    </a:lnR>
+                    <a:lnT w="6350" cap="flat" cmpd="sng" algn="ctr">
+                      <a:solidFill>
+                        <a:srgbClr val="B7C4CC"/>
+                      </a:solidFill>
+                      <a:prstDash val="solid"/>
+                      <a:round/>
+                      <a:headEnd type="none" w="med" len="med"/>
+                      <a:tailEnd type="none" w="med" len="med"/>
+                    </a:lnT>
+                    <a:lnB w="6350" cap="flat" cmpd="sng" algn="ctr">
+                      <a:solidFill>
+                        <a:srgbClr val="B7C4CC"/>
+                      </a:solidFill>
+                      <a:prstDash val="solid"/>
+                      <a:round/>
+                      <a:headEnd type="none" w="med" len="med"/>
+                      <a:tailEnd type="none" w="med" len="med"/>
+                    </a:lnB>
+                    <a:solidFill>
+                      <a:srgbClr val="FFFFFF"/>
+                    </a:solidFill>
+                  </a:tcPr>
+                </a:tc>
+                <a:tc>
+                  <a:txBody>
+                    <a:bodyPr/>
+                    <a:lstStyle/>
+                    <a:p>
+                      <a:pPr marL="0" indent="0">
+                        <a:buNone/>
+                      </a:pPr>
+                      <a:r>
+                        <a:rPr lang="en-US" sz="1100">
+                          <a:solidFill>
+                            <a:srgbClr val="1B2227"/>
+                          </a:solidFill>
+                          <a:latin typeface="Calibri" pitchFamily="34" charset="0"/>
+                          <a:ea typeface="Calibri" pitchFamily="34" charset="-122"/>
+                          <a:cs typeface="Calibri" pitchFamily="34" charset="-120"/>
+                        </a:rPr>
+                        <a:t>Multi-agent / multi-step orchestration with failure handling, recovery, observability.</a:t>
+                      </a:r>
+                      <a:endParaRPr lang="en-US" sz="1100">
+                        <a:latin typeface="Calibri" charset="0"/>
+                        <a:ea typeface="Calibri" charset="0"/>
+                        <a:cs typeface="Calibri" charset="0"/>
+                      </a:endParaRPr>
+                    </a:p>
+                  </a:txBody>
+                  <a:tcPr anchor="ctr">
+                    <a:lnL w="6350" cap="flat" cmpd="sng" algn="ctr">
+                      <a:solidFill>
+                        <a:srgbClr val="B7C4CC"/>
+                      </a:solidFill>
+                      <a:prstDash val="solid"/>
+                      <a:round/>
+                      <a:headEnd type="none" w="med" len="med"/>
+                      <a:tailEnd type="none" w="med" len="med"/>
+                    </a:lnL>
+                    <a:lnR w="6350" cap="flat" cmpd="sng" algn="ctr">
+                      <a:solidFill>
+                        <a:srgbClr val="B7C4CC"/>
+                      </a:solidFill>
+                      <a:prstDash val="solid"/>
+                      <a:round/>
+                      <a:headEnd type="none" w="med" len="med"/>
+                      <a:tailEnd type="none" w="med" len="med"/>
+                    </a:lnR>
+                    <a:lnT w="6350" cap="flat" cmpd="sng" algn="ctr">
+                      <a:solidFill>
+                        <a:srgbClr val="B7C4CC"/>
+                      </a:solidFill>
+                      <a:prstDash val="solid"/>
+                      <a:round/>
+                      <a:headEnd type="none" w="med" len="med"/>
+                      <a:tailEnd type="none" w="med" len="med"/>
+                    </a:lnT>
+                    <a:lnB w="6350" cap="flat" cmpd="sng" algn="ctr">
+                      <a:solidFill>
+                        <a:srgbClr val="B7C4CC"/>
+                      </a:solidFill>
+                      <a:prstDash val="solid"/>
+                      <a:round/>
+                      <a:headEnd type="none" w="med" len="med"/>
+                      <a:tailEnd type="none" w="med" len="med"/>
+                    </a:lnB>
+                    <a:solidFill>
+                      <a:srgbClr val="FFFFFF"/>
+                    </a:solidFill>
+                  </a:tcPr>
+                </a:tc>
+                <a:tc>
+                  <a:txBody>
+                    <a:bodyPr/>
+                    <a:lstStyle/>
+                    <a:p>
+                      <a:pPr marL="0" indent="0" algn="ctr">
+                        <a:buNone/>
+                      </a:pPr>
+                      <a:r>
+                        <a:rPr lang="en-US" sz="1100" b="1">
+                          <a:solidFill>
+                            <a:srgbClr val="1B2227"/>
+                          </a:solidFill>
+                          <a:latin typeface="Calibri" pitchFamily="34" charset="0"/>
+                          <a:ea typeface="Calibri" pitchFamily="34" charset="-122"/>
+                          <a:cs typeface="Calibri" pitchFamily="34" charset="-120"/>
+                        </a:rPr>
+                        <a:t>30</a:t>
+                      </a:r>
+                      <a:endParaRPr lang="en-US" sz="1100">
+                        <a:latin typeface="Calibri" charset="0"/>
+                        <a:ea typeface="Calibri" charset="0"/>
+                        <a:cs typeface="Calibri" charset="0"/>
+                      </a:endParaRPr>
+                    </a:p>
+                  </a:txBody>
+                  <a:tcPr anchor="ctr">
+                    <a:lnL w="6350" cap="flat" cmpd="sng" algn="ctr">
+                      <a:solidFill>
+                        <a:srgbClr val="B7C4CC"/>
+                      </a:solidFill>
+                      <a:prstDash val="solid"/>
+                      <a:round/>
+                      <a:headEnd type="none" w="med" len="med"/>
+                      <a:tailEnd type="none" w="med" len="med"/>
+                    </a:lnL>
+                    <a:lnR w="6350" cap="flat" cmpd="sng" algn="ctr">
+                      <a:solidFill>
+                        <a:srgbClr val="B7C4CC"/>
+                      </a:solidFill>
+                      <a:prstDash val="solid"/>
+                      <a:round/>
+                      <a:headEnd type="none" w="med" len="med"/>
+                      <a:tailEnd type="none" w="med" len="med"/>
+                    </a:lnR>
+                    <a:lnT w="6350" cap="flat" cmpd="sng" algn="ctr">
+                      <a:solidFill>
+                        <a:srgbClr val="B7C4CC"/>
+                      </a:solidFill>
+                      <a:prstDash val="solid"/>
+                      <a:round/>
+                      <a:headEnd type="none" w="med" len="med"/>
+                      <a:tailEnd type="none" w="med" len="med"/>
+                    </a:lnT>
+                    <a:lnB w="6350" cap="flat" cmpd="sng" algn="ctr">
+                      <a:solidFill>
+                        <a:srgbClr val="B7C4CC"/>
+                      </a:solidFill>
+                      <a:prstDash val="solid"/>
+                      <a:round/>
+                      <a:headEnd type="none" w="med" len="med"/>
+                      <a:tailEnd type="none" w="med" len="med"/>
+                    </a:lnB>
+                    <a:solidFill>
+                      <a:srgbClr val="FFFFFF"/>
+                    </a:solidFill>
+                  </a:tcPr>
+                </a:tc>
+                <a:extLst>
+                  <a:ext uri="{0D108BD9-81ED-4DB2-BD59-A6C34878D82A}">
+                    <a16:rowId xmlns:a16="http://schemas.microsoft.com/office/drawing/2014/main" val="10004"/>
+                  </a:ext>
+                </a:extLst>
+              </a:tr>
+              <a:tr h="566928">
+                <a:tc>
+                  <a:txBody>
+                    <a:bodyPr/>
+                    <a:lstStyle/>
+                    <a:p>
+                      <a:pPr marL="0" indent="0">
+                        <a:buNone/>
+                      </a:pPr>
+                      <a:r>
+                        <a:rPr lang="en-US" sz="1100" b="1">
+                          <a:solidFill>
+                            <a:srgbClr val="024879"/>
+                          </a:solidFill>
+                          <a:latin typeface="Calibri" pitchFamily="34" charset="0"/>
+                          <a:ea typeface="Calibri" pitchFamily="34" charset="-122"/>
+                          <a:cs typeface="Calibri" pitchFamily="34" charset="-120"/>
+                        </a:rPr>
+                        <a:t>AI Tool Integration &amp; Extensibility</a:t>
+                      </a:r>
+                      <a:endParaRPr lang="en-US" sz="1100">
+                        <a:latin typeface="Calibri" charset="0"/>
+                        <a:ea typeface="Calibri" charset="0"/>
+                        <a:cs typeface="Calibri" charset="0"/>
+                      </a:endParaRPr>
+                    </a:p>
+                  </a:txBody>
+                  <a:tcPr anchor="ctr">
+                    <a:lnL w="6350" cap="flat" cmpd="sng" algn="ctr">
+                      <a:solidFill>
+                        <a:srgbClr val="B7C4CC"/>
+                      </a:solidFill>
+                      <a:prstDash val="solid"/>
+                      <a:round/>
+                      <a:headEnd type="none" w="med" len="med"/>
+                      <a:tailEnd type="none" w="med" len="med"/>
+                    </a:lnL>
+                    <a:lnR w="6350" cap="flat" cmpd="sng" algn="ctr">
+                      <a:solidFill>
+                        <a:srgbClr val="B7C4CC"/>
+                      </a:solidFill>
+                      <a:prstDash val="solid"/>
+                      <a:round/>
+                      <a:headEnd type="none" w="med" len="med"/>
+                      <a:tailEnd type="none" w="med" len="med"/>
+                    </a:lnR>
+                    <a:lnT w="6350" cap="flat" cmpd="sng" algn="ctr">
+                      <a:solidFill>
+                        <a:srgbClr val="B7C4CC"/>
+                      </a:solidFill>
+                      <a:prstDash val="solid"/>
+                      <a:round/>
+                      <a:headEnd type="none" w="med" len="med"/>
+                      <a:tailEnd type="none" w="med" len="med"/>
+                    </a:lnT>
+                    <a:lnB w="6350" cap="flat" cmpd="sng" algn="ctr">
+                      <a:solidFill>
+                        <a:srgbClr val="B7C4CC"/>
+                      </a:solidFill>
+                      <a:prstDash val="solid"/>
+                      <a:round/>
+                      <a:headEnd type="none" w="med" len="med"/>
+                      <a:tailEnd type="none" w="med" len="med"/>
+                    </a:lnB>
+                    <a:solidFill>
+                      <a:srgbClr val="DFE7ED"/>
+                    </a:solidFill>
+                  </a:tcPr>
+                </a:tc>
+                <a:tc>
+                  <a:txBody>
+                    <a:bodyPr/>
+                    <a:lstStyle/>
+                    <a:p>
+                      <a:pPr marL="0" indent="0">
+                        <a:buNone/>
+                      </a:pPr>
+                      <a:r>
+                        <a:rPr lang="en-US" sz="1100">
+                          <a:solidFill>
+                            <a:srgbClr val="1B2227"/>
+                          </a:solidFill>
+                          <a:latin typeface="Calibri" pitchFamily="34" charset="0"/>
+                          <a:ea typeface="Calibri" pitchFamily="34" charset="-122"/>
+                          <a:cs typeface="Calibri" pitchFamily="34" charset="-120"/>
+                        </a:rPr>
+                        <a:t>Extended agents via MCP servers, hooks, or custom skills/tools — secure and reusable.</a:t>
+                      </a:r>
+                      <a:endParaRPr lang="en-US" sz="1100">
+                        <a:latin typeface="Calibri" charset="0"/>
+                        <a:ea typeface="Calibri" charset="0"/>
+                        <a:cs typeface="Calibri" charset="0"/>
+                      </a:endParaRPr>
+                    </a:p>
+                  </a:txBody>
+                  <a:tcPr anchor="ctr">
+                    <a:lnL w="6350" cap="flat" cmpd="sng" algn="ctr">
+                      <a:solidFill>
+                        <a:srgbClr val="B7C4CC"/>
+                      </a:solidFill>
+                      <a:prstDash val="solid"/>
+                      <a:round/>
+                      <a:headEnd type="none" w="med" len="med"/>
+                      <a:tailEnd type="none" w="med" len="med"/>
+                    </a:lnL>
+                    <a:lnR w="6350" cap="flat" cmpd="sng" algn="ctr">
+                      <a:solidFill>
+                        <a:srgbClr val="B7C4CC"/>
+                      </a:solidFill>
+                      <a:prstDash val="solid"/>
+                      <a:round/>
+                      <a:headEnd type="none" w="med" len="med"/>
+                      <a:tailEnd type="none" w="med" len="med"/>
+                    </a:lnR>
+                    <a:lnT w="6350" cap="flat" cmpd="sng" algn="ctr">
+                      <a:solidFill>
+                        <a:srgbClr val="B7C4CC"/>
+                      </a:solidFill>
+                      <a:prstDash val="solid"/>
+                      <a:round/>
+                      <a:headEnd type="none" w="med" len="med"/>
+                      <a:tailEnd type="none" w="med" len="med"/>
+                    </a:lnT>
+                    <a:lnB w="6350" cap="flat" cmpd="sng" algn="ctr">
+                      <a:solidFill>
+                        <a:srgbClr val="B7C4CC"/>
+                      </a:solidFill>
+                      <a:prstDash val="solid"/>
+                      <a:round/>
+                      <a:headEnd type="none" w="med" len="med"/>
+                      <a:tailEnd type="none" w="med" len="med"/>
+                    </a:lnB>
+                    <a:solidFill>
+                      <a:srgbClr val="DFE7ED"/>
+                    </a:solidFill>
+                  </a:tcPr>
+                </a:tc>
+                <a:tc>
+                  <a:txBody>
+                    <a:bodyPr/>
+                    <a:lstStyle/>
+                    <a:p>
+                      <a:pPr marL="0" indent="0" algn="ctr">
+                        <a:buNone/>
+                      </a:pPr>
+                      <a:r>
+                        <a:rPr lang="en-US" sz="1100" b="1">
+                          <a:solidFill>
+                            <a:srgbClr val="1B2227"/>
+                          </a:solidFill>
+                          <a:latin typeface="Calibri" pitchFamily="34" charset="0"/>
+                          <a:ea typeface="Calibri" pitchFamily="34" charset="-122"/>
+                          <a:cs typeface="Calibri" pitchFamily="34" charset="-120"/>
+                        </a:rPr>
+                        <a:t>30</a:t>
+                      </a:r>
+                      <a:endParaRPr lang="en-US" sz="1100">
+                        <a:latin typeface="Calibri" charset="0"/>
+                        <a:ea typeface="Calibri" charset="0"/>
+                        <a:cs typeface="Calibri" charset="0"/>
+                      </a:endParaRPr>
+                    </a:p>
+                  </a:txBody>
+                  <a:tcPr anchor="ctr">
+                    <a:lnL w="6350" cap="flat" cmpd="sng" algn="ctr">
+                      <a:solidFill>
+                        <a:srgbClr val="B7C4CC"/>
+                      </a:solidFill>
+                      <a:prstDash val="solid"/>
+                      <a:round/>
+                      <a:headEnd type="none" w="med" len="med"/>
+                      <a:tailEnd type="none" w="med" len="med"/>
+                    </a:lnL>
+                    <a:lnR w="6350" cap="flat" cmpd="sng" algn="ctr">
+                      <a:solidFill>
+                        <a:srgbClr val="B7C4CC"/>
+                      </a:solidFill>
+                      <a:prstDash val="solid"/>
+                      <a:round/>
+                      <a:headEnd type="none" w="med" len="med"/>
+                      <a:tailEnd type="none" w="med" len="med"/>
+                    </a:lnR>
+                    <a:lnT w="6350" cap="flat" cmpd="sng" algn="ctr">
+                      <a:solidFill>
+                        <a:srgbClr val="B7C4CC"/>
+                      </a:solidFill>
+                      <a:prstDash val="solid"/>
+                      <a:round/>
+                      <a:headEnd type="none" w="med" len="med"/>
+                      <a:tailEnd type="none" w="med" len="med"/>
+                    </a:lnT>
+                    <a:lnB w="6350" cap="flat" cmpd="sng" algn="ctr">
+                      <a:solidFill>
+                        <a:srgbClr val="B7C4CC"/>
+                      </a:solidFill>
+                      <a:prstDash val="solid"/>
+                      <a:round/>
+                      <a:headEnd type="none" w="med" len="med"/>
+                      <a:tailEnd type="none" w="med" len="med"/>
+                    </a:lnB>
+                    <a:solidFill>
+                      <a:srgbClr val="DFE7ED"/>
+                    </a:solidFill>
+                  </a:tcPr>
+                </a:tc>
+                <a:extLst>
+                  <a:ext uri="{0D108BD9-81ED-4DB2-BD59-A6C34878D82A}">
+                    <a16:rowId xmlns:a16="http://schemas.microsoft.com/office/drawing/2014/main" val="10005"/>
+                  </a:ext>
+                </a:extLst>
+              </a:tr>
+            </a:tbl>
+          </a:graphicData>
+        </a:graphic>
+      </p:graphicFrame>
+      <p:sp>
+        <p:nvSpPr>
+          <p:cNvPr id="6" name="Shape 2"/>
+          <p:cNvSpPr/>
+          <p:nvPr/>
+        </p:nvSpPr>
+        <p:spPr>
+          <a:xfrm>
+            <a:off x="457200" y="4526280"/>
+            <a:ext cx="1965960" cy="411480"/>
+          </a:xfrm>
+          <a:prstGeom prst="roundRect">
+            <a:avLst>
+              <a:gd name="adj" fmla="val 8889"/>
+            </a:avLst>
+          </a:prstGeom>
+          <a:solidFill>
+            <a:srgbClr val="71D8C5"/>
+          </a:solidFill>
+          <a:ln w="9525">
+            <a:solidFill>
+              <a:srgbClr val="B7C4CC"/>
+            </a:solidFill>
+            <a:prstDash val="solid"/>
+          </a:ln>
+        </p:spPr>
+        <p:txBody>
+          <a:bodyPr/>
+          <a:lstStyle/>
+          <a:p>
+            <a:endParaRPr lang="en-US"/>
+          </a:p>
+        </p:txBody>
+      </p:sp>
+      <p:sp>
+        <p:nvSpPr>
+          <p:cNvPr id="7" name="Text 3"/>
+          <p:cNvSpPr/>
+          <p:nvPr/>
+        </p:nvSpPr>
+        <p:spPr>
+          <a:xfrm>
+            <a:off x="457200" y="4526280"/>
+            <a:ext cx="1965960" cy="411480"/>
+          </a:xfrm>
+          <a:prstGeom prst="rect">
+            <a:avLst/>
+          </a:prstGeom>
+          <a:noFill/>
+          <a:ln/>
+        </p:spPr>
+        <p:txBody>
+          <a:bodyPr wrap="square" rtlCol="0" anchor="ctr"/>
+          <a:lstStyle/>
+          <a:p>
+            <a:pPr marL="0" indent="0" algn="ctr">
+              <a:buNone/>
+            </a:pPr>
+            <a:r>
+              <a:rPr lang="en-US" sz="1000" b="1">
+                <a:solidFill>
+                  <a:srgbClr val="1B2227"/>
+                </a:solidFill>
+                <a:latin typeface="Arial" pitchFamily="34" charset="0"/>
+                <a:ea typeface="Arial" pitchFamily="34" charset="-122"/>
+                <a:cs typeface="Arial" pitchFamily="34" charset="-120"/>
+              </a:rPr>
+              <a:t>Distinction  25–30</a:t>
+            </a:r>
+            <a:endParaRPr lang="en-US" sz="1000"/>
+          </a:p>
+        </p:txBody>
+      </p:sp>
+      <p:sp>
+        <p:nvSpPr>
+          <p:cNvPr id="8" name="Shape 4"/>
+          <p:cNvSpPr/>
+          <p:nvPr/>
+        </p:nvSpPr>
+        <p:spPr>
+          <a:xfrm>
+            <a:off x="2532888" y="4526280"/>
+            <a:ext cx="1965960" cy="411480"/>
+          </a:xfrm>
+          <a:prstGeom prst="roundRect">
+            <a:avLst>
+              <a:gd name="adj" fmla="val 8889"/>
+            </a:avLst>
+          </a:prstGeom>
+          <a:solidFill>
+            <a:srgbClr val="C5DCEE"/>
+          </a:solidFill>
+          <a:ln w="9525">
+            <a:solidFill>
+              <a:srgbClr val="B7C4CC"/>
+            </a:solidFill>
+            <a:prstDash val="solid"/>
+          </a:ln>
+        </p:spPr>
+        <p:txBody>
+          <a:bodyPr/>
+          <a:lstStyle/>
+          <a:p>
+            <a:endParaRPr lang="en-US"/>
+          </a:p>
+        </p:txBody>
+      </p:sp>
+      <p:sp>
+        <p:nvSpPr>
+          <p:cNvPr id="9" name="Text 5"/>
+          <p:cNvSpPr/>
+          <p:nvPr/>
+        </p:nvSpPr>
+        <p:spPr>
+          <a:xfrm>
+            <a:off x="2532888" y="4526280"/>
+            <a:ext cx="1965960" cy="411480"/>
+          </a:xfrm>
+          <a:prstGeom prst="rect">
+            <a:avLst/>
+          </a:prstGeom>
+          <a:noFill/>
+          <a:ln/>
+        </p:spPr>
+        <p:txBody>
+          <a:bodyPr wrap="square" rtlCol="0" anchor="ctr"/>
+          <a:lstStyle/>
+          <a:p>
+            <a:pPr marL="0" indent="0" algn="ctr">
+              <a:buNone/>
+            </a:pPr>
+            <a:r>
+              <a:rPr lang="en-US" sz="1000" b="1">
+                <a:solidFill>
+                  <a:srgbClr val="1B2227"/>
+                </a:solidFill>
+                <a:latin typeface="Arial" pitchFamily="34" charset="0"/>
+                <a:ea typeface="Arial" pitchFamily="34" charset="-122"/>
+                <a:cs typeface="Arial" pitchFamily="34" charset="-120"/>
+              </a:rPr>
+              <a:t>Proficient  18–24</a:t>
+            </a:r>
+            <a:endParaRPr lang="en-US" sz="1000"/>
+          </a:p>
+        </p:txBody>
+      </p:sp>
+      <p:sp>
+        <p:nvSpPr>
+          <p:cNvPr id="10" name="Shape 6"/>
+          <p:cNvSpPr/>
+          <p:nvPr/>
+        </p:nvSpPr>
+        <p:spPr>
+          <a:xfrm>
+            <a:off x="4608576" y="4526280"/>
+            <a:ext cx="1965960" cy="411480"/>
+          </a:xfrm>
+          <a:prstGeom prst="roundRect">
+            <a:avLst>
+              <a:gd name="adj" fmla="val 8889"/>
+            </a:avLst>
+          </a:prstGeom>
+          <a:solidFill>
+            <a:srgbClr val="DFE7ED"/>
+          </a:solidFill>
+          <a:ln w="9525">
+            <a:solidFill>
+              <a:srgbClr val="B7C4CC"/>
+            </a:solidFill>
+            <a:prstDash val="solid"/>
+          </a:ln>
+        </p:spPr>
+        <p:txBody>
+          <a:bodyPr/>
+          <a:lstStyle/>
+          <a:p>
+            <a:endParaRPr lang="en-US"/>
+          </a:p>
+        </p:txBody>
+      </p:sp>
+      <p:sp>
+        <p:nvSpPr>
+          <p:cNvPr id="5" name="Text 7"/>
+          <p:cNvSpPr/>
+          <p:nvPr/>
+        </p:nvSpPr>
+        <p:spPr>
+          <a:xfrm>
+            <a:off x="4608576" y="4526280"/>
+            <a:ext cx="1965960" cy="411480"/>
+          </a:xfrm>
+          <a:prstGeom prst="rect">
+            <a:avLst/>
+          </a:prstGeom>
+          <a:noFill/>
+          <a:ln/>
+        </p:spPr>
+        <p:txBody>
+          <a:bodyPr wrap="square" rtlCol="0" anchor="ctr"/>
+          <a:lstStyle/>
+          <a:p>
+            <a:pPr marL="0" indent="0" algn="ctr">
+              <a:buNone/>
+            </a:pPr>
+            <a:r>
+              <a:rPr lang="en-US" sz="1000" b="1">
+                <a:solidFill>
+                  <a:srgbClr val="1B2227"/>
+                </a:solidFill>
+                <a:latin typeface="Arial" pitchFamily="34" charset="0"/>
+                <a:ea typeface="Arial" pitchFamily="34" charset="-122"/>
+                <a:cs typeface="Arial" pitchFamily="34" charset="-120"/>
+              </a:rPr>
+              <a:t>Developing  10–17</a:t>
+            </a:r>
+            <a:endParaRPr lang="en-US" sz="1000"/>
+          </a:p>
+        </p:txBody>
+      </p:sp>
+      <p:sp>
+        <p:nvSpPr>
+          <p:cNvPr id="12" name="Shape 8"/>
+          <p:cNvSpPr/>
+          <p:nvPr/>
+        </p:nvSpPr>
+        <p:spPr>
+          <a:xfrm>
+            <a:off x="6684264" y="4526280"/>
+            <a:ext cx="1965960" cy="411480"/>
+          </a:xfrm>
+          <a:prstGeom prst="roundRect">
+            <a:avLst>
+              <a:gd name="adj" fmla="val 8889"/>
+            </a:avLst>
+          </a:prstGeom>
+          <a:solidFill>
+            <a:srgbClr val="FFFFFF"/>
+          </a:solidFill>
+          <a:ln w="9525">
+            <a:solidFill>
+              <a:srgbClr val="B7C4CC"/>
+            </a:solidFill>
+            <a:prstDash val="solid"/>
+          </a:ln>
+        </p:spPr>
+        <p:txBody>
+          <a:bodyPr/>
+          <a:lstStyle/>
+          <a:p>
+            <a:endParaRPr lang="en-US"/>
+          </a:p>
+        </p:txBody>
+      </p:sp>
+      <p:sp>
+        <p:nvSpPr>
+          <p:cNvPr id="13" name="Text 9"/>
+          <p:cNvSpPr/>
+          <p:nvPr/>
+        </p:nvSpPr>
+        <p:spPr>
+          <a:xfrm>
+            <a:off x="6684264" y="4526280"/>
+            <a:ext cx="1965960" cy="411480"/>
+          </a:xfrm>
+          <a:prstGeom prst="rect">
+            <a:avLst/>
+          </a:prstGeom>
+          <a:noFill/>
+          <a:ln/>
+        </p:spPr>
+        <p:txBody>
+          <a:bodyPr wrap="square" rtlCol="0" anchor="ctr"/>
+          <a:lstStyle/>
+          <a:p>
+            <a:pPr marL="0" indent="0" algn="ctr">
+              <a:buNone/>
+            </a:pPr>
+            <a:r>
+              <a:rPr lang="en-US" sz="1000" b="1">
+                <a:solidFill>
+                  <a:srgbClr val="1B2227"/>
+                </a:solidFill>
+                <a:latin typeface="Arial" pitchFamily="34" charset="0"/>
+                <a:ea typeface="Arial" pitchFamily="34" charset="-122"/>
+                <a:cs typeface="Arial" pitchFamily="34" charset="-120"/>
+              </a:rPr>
+              <a:t>Emerging  0–9</a:t>
+            </a:r>
+            <a:endParaRPr lang="en-US" sz="1000"/>
           </a:p>
         </p:txBody>
       </p:sp>
@@ -14311,6 +13475,27 @@
 </file>
 
 <file path=customXml/item1.xml><?xml version="1.0" encoding="utf-8"?>
+<p:properties xmlns:p="http://schemas.microsoft.com/office/2006/metadata/properties" xmlns:xsi="http://www.w3.org/2001/XMLSchema-instance" xmlns:pc="http://schemas.microsoft.com/office/infopath/2007/PartnerControls">
+  <documentManagement>
+    <lcf76f155ced4ddcb4097134ff3c332f xmlns="726f94d6-fa4c-4578-9923-387e8e08487a">
+      <Terms xmlns="http://schemas.microsoft.com/office/infopath/2007/PartnerControls"/>
+    </lcf76f155ced4ddcb4097134ff3c332f>
+    <TaxCatchAll xmlns="7a392144-d9c7-4700-81e3-5d9ccc7560d2" xsi:nil="true"/>
+    <Fecha_x002f_hora xmlns="726f94d6-fa4c-4578-9923-387e8e08487a" xsi:nil="true"/>
+  </documentManagement>
+</p:properties>
+</file>
+
+<file path=customXml/item2.xml><?xml version="1.0" encoding="utf-8"?>
+<?mso-contentType ?>
+<FormTemplates xmlns="http://schemas.microsoft.com/sharepoint/v3/contenttype/forms">
+  <Display>DocumentLibraryForm</Display>
+  <Edit>DocumentLibraryForm</Edit>
+  <New>DocumentLibraryForm</New>
+</FormTemplates>
+</file>
+
+<file path=customXml/item3.xml><?xml version="1.0" encoding="utf-8"?>
 <ct:contentTypeSchema xmlns:ct="http://schemas.microsoft.com/office/2006/metadata/contentType" xmlns:ma="http://schemas.microsoft.com/office/2006/metadata/properties/metaAttributes" ct:_="" ma:_="" ma:contentTypeName="Document" ma:contentTypeID="0x010100178BDE5FBDD49645B4C97074EE65F842" ma:contentTypeVersion="12" ma:contentTypeDescription="Create a new document." ma:contentTypeScope="" ma:versionID="5312b329c996433ceb2b53c55abbd94c">
   <xsd:schema xmlns:xsd="http://www.w3.org/2001/XMLSchema" xmlns:xs="http://www.w3.org/2001/XMLSchema" xmlns:p="http://schemas.microsoft.com/office/2006/metadata/properties" xmlns:ns2="726f94d6-fa4c-4578-9923-387e8e08487a" xmlns:ns3="7a392144-d9c7-4700-81e3-5d9ccc7560d2" targetNamespace="http://schemas.microsoft.com/office/2006/metadata/properties" ma:root="true" ma:fieldsID="4c00a87271a249586203d6baa24a7578" ns2:_="" ns3:_="">
     <xsd:import namespace="726f94d6-fa4c-4578-9923-387e8e08487a"/>
@@ -14511,28 +13696,32 @@
 </ct:contentTypeSchema>
 </file>
 
-<file path=customXml/item2.xml><?xml version="1.0" encoding="utf-8"?>
-<?mso-contentType ?>
-<FormTemplates xmlns="http://schemas.microsoft.com/sharepoint/v3/contenttype/forms">
-  <Display>DocumentLibraryForm</Display>
-  <Edit>DocumentLibraryForm</Edit>
-  <New>DocumentLibraryForm</New>
-</FormTemplates>
+<file path=customXml/itemProps1.xml><?xml version="1.0" encoding="utf-8"?>
+<ds:datastoreItem xmlns:ds="http://schemas.openxmlformats.org/officeDocument/2006/customXml" ds:itemID="{6C7FDC5A-70C0-4588-82CA-E8B6F6B3A12D}">
+  <ds:schemaRefs>
+    <ds:schemaRef ds:uri="http://schemas.openxmlformats.org/package/2006/metadata/core-properties"/>
+    <ds:schemaRef ds:uri="http://schemas.microsoft.com/office/2006/metadata/properties"/>
+    <ds:schemaRef ds:uri="http://purl.org/dc/terms/"/>
+    <ds:schemaRef ds:uri="http://purl.org/dc/dcmitype/"/>
+    <ds:schemaRef ds:uri="http://purl.org/dc/elements/1.1/"/>
+    <ds:schemaRef ds:uri="http://www.w3.org/XML/1998/namespace"/>
+    <ds:schemaRef ds:uri="http://schemas.microsoft.com/office/2006/documentManagement/types"/>
+    <ds:schemaRef ds:uri="http://schemas.microsoft.com/office/infopath/2007/PartnerControls"/>
+    <ds:schemaRef ds:uri="7a392144-d9c7-4700-81e3-5d9ccc7560d2"/>
+    <ds:schemaRef ds:uri="726f94d6-fa4c-4578-9923-387e8e08487a"/>
+  </ds:schemaRefs>
+</ds:datastoreItem>
 </file>
 
-<file path=customXml/item3.xml><?xml version="1.0" encoding="utf-8"?>
-<p:properties xmlns:p="http://schemas.microsoft.com/office/2006/metadata/properties" xmlns:xsi="http://www.w3.org/2001/XMLSchema-instance" xmlns:pc="http://schemas.microsoft.com/office/infopath/2007/PartnerControls">
-  <documentManagement>
-    <lcf76f155ced4ddcb4097134ff3c332f xmlns="726f94d6-fa4c-4578-9923-387e8e08487a">
-      <Terms xmlns="http://schemas.microsoft.com/office/infopath/2007/PartnerControls"/>
-    </lcf76f155ced4ddcb4097134ff3c332f>
-    <TaxCatchAll xmlns="7a392144-d9c7-4700-81e3-5d9ccc7560d2" xsi:nil="true"/>
-    <Fecha_x002f_hora xmlns="726f94d6-fa4c-4578-9923-387e8e08487a" xsi:nil="true"/>
-  </documentManagement>
-</p:properties>
+<file path=customXml/itemProps2.xml><?xml version="1.0" encoding="utf-8"?>
+<ds:datastoreItem xmlns:ds="http://schemas.openxmlformats.org/officeDocument/2006/customXml" ds:itemID="{D68DD810-7AED-43B6-BB17-F254283372F2}">
+  <ds:schemaRefs>
+    <ds:schemaRef ds:uri="http://schemas.microsoft.com/sharepoint/v3/contenttype/forms"/>
+  </ds:schemaRefs>
+</ds:datastoreItem>
 </file>
 
-<file path=customXml/itemProps1.xml><?xml version="1.0" encoding="utf-8"?>
+<file path=customXml/itemProps3.xml><?xml version="1.0" encoding="utf-8"?>
 <ds:datastoreItem xmlns:ds="http://schemas.openxmlformats.org/officeDocument/2006/customXml" ds:itemID="{22674E81-17EB-43AD-A4DC-3DD0F2DF9E2A}">
   <ds:schemaRefs>
     <ds:schemaRef ds:uri="726f94d6-fa4c-4578-9923-387e8e08487a"/>
@@ -14549,29 +13738,4 @@
     <ds:schemaRef ds:uri="http://www.w3.org/2001/XMLSchema"/>
   </ds:schemaRefs>
 </ds:datastoreItem>
-</file>
-
-<file path=customXml/itemProps2.xml><?xml version="1.0" encoding="utf-8"?>
-<ds:datastoreItem xmlns:ds="http://schemas.openxmlformats.org/officeDocument/2006/customXml" ds:itemID="{D68DD810-7AED-43B6-BB17-F254283372F2}">
-  <ds:schemaRefs>
-    <ds:schemaRef ds:uri="http://schemas.microsoft.com/sharepoint/v3/contenttype/forms"/>
-  </ds:schemaRefs>
-</ds:datastoreItem>
-</file>
-
-<file path=customXml/itemProps3.xml><?xml version="1.0" encoding="utf-8"?>
-<ds:datastoreItem xmlns:ds="http://schemas.openxmlformats.org/officeDocument/2006/customXml" ds:itemID="{6C7FDC5A-70C0-4588-82CA-E8B6F6B3A12D}">
-  <ds:schemaRefs>
-    <ds:schemaRef ds:uri="http://schemas.openxmlformats.org/package/2006/metadata/core-properties"/>
-    <ds:schemaRef ds:uri="http://schemas.microsoft.com/office/2006/metadata/properties"/>
-    <ds:schemaRef ds:uri="http://purl.org/dc/terms/"/>
-    <ds:schemaRef ds:uri="http://purl.org/dc/dcmitype/"/>
-    <ds:schemaRef ds:uri="http://purl.org/dc/elements/1.1/"/>
-    <ds:schemaRef ds:uri="http://www.w3.org/XML/1998/namespace"/>
-    <ds:schemaRef ds:uri="http://schemas.microsoft.com/office/2006/documentManagement/types"/>
-    <ds:schemaRef ds:uri="http://schemas.microsoft.com/office/infopath/2007/PartnerControls"/>
-    <ds:schemaRef ds:uri="7a392144-d9c7-4700-81e3-5d9ccc7560d2"/>
-    <ds:schemaRef ds:uri="726f94d6-fa4c-4578-9923-387e8e08487a"/>
-  </ds:schemaRefs>
-</ds:datastoreItem>
 </file>
</xml_diff>